<commit_message>
vault backup: 2026-09-25 13:59:39
</commit_message>
<xml_diff>
--- a/SDLC/Projects/TMP-oracle-route-lookup — Oracle route lookup/assets/Oracle route lookup.pptx
+++ b/SDLC/Projects/TMP-oracle-route-lookup — Oracle route lookup/assets/Oracle route lookup.pptx
@@ -14,10 +14,9 @@
     <p:sldId id="262" r:id="rId8"/>
     <p:sldId id="263" r:id="rId9"/>
     <p:sldId id="264" r:id="rId10"/>
-    <p:sldId id="265" r:id="rId11"/>
   </p:sldIdLst>
   <p:notesMasterIdLst>
-    <p:notesMasterId r:id="rId12"/>
+    <p:notesMasterId r:id="rId11"/>
   </p:notesMasterIdLst>
   <p:sldSz cx="12192000" cy="6858000"/>
   <p:notesSz cx="6858000" cy="12192000"/>
@@ -553,94 +552,6 @@
 </p:notes>
 </file>
 
-<file path=ppt/notesSlides/notesSlide10.xml><?xml version="1.0" encoding="utf-8"?>
-<p:notes xmlns:a="http://schemas.openxmlformats.org/drawingml/2006/main" xmlns:r="http://schemas.openxmlformats.org/officeDocument/2006/relationships" xmlns:p="http://schemas.openxmlformats.org/presentationml/2006/main">
-  <p:cSld>
-    <p:spTree>
-      <p:nvGrpSpPr>
-        <p:cNvPr id="1" name=""/>
-        <p:cNvGrpSpPr/>
-        <p:nvPr/>
-      </p:nvGrpSpPr>
-      <p:grpSpPr>
-        <a:xfrm>
-          <a:off x="0" y="0"/>
-          <a:ext cx="0" cy="0"/>
-          <a:chOff x="0" y="0"/>
-          <a:chExt cx="0" cy="0"/>
-        </a:xfrm>
-      </p:grpSpPr>
-      <p:sp>
-        <p:nvSpPr>
-          <p:cNvPr id="2" name="Slide Image Placeholder 1"/>
-          <p:cNvSpPr>
-            <a:spLocks noGrp="1" noRot="1" noChangeAspect="1"/>
-          </p:cNvSpPr>
-          <p:nvPr>
-            <p:ph type="sldImg"/>
-          </p:nvPr>
-        </p:nvSpPr>
-        <p:spPr/>
-      </p:sp>
-      <p:sp>
-        <p:nvSpPr>
-          <p:cNvPr id="3" name="Notes Placeholder 2"/>
-          <p:cNvSpPr>
-            <a:spLocks noGrp="1"/>
-          </p:cNvSpPr>
-          <p:nvPr>
-            <p:ph type="body" idx="1"/>
-          </p:nvPr>
-        </p:nvSpPr>
-        <p:spPr/>
-        <p:txBody>
-          <a:bodyPr/>
-          <a:lstStyle/>
-          <a:p>
-            <a:r>
-              <a:rPr lang="en-US" dirty="0"/>
-              <a:t>After the room, write any CP3 actions back onto the design note. This deck does not close the review gate.</a:t>
-            </a:r>
-            <a:endParaRPr lang="en-US" dirty="0"/>
-          </a:p>
-        </p:txBody>
-      </p:sp>
-      <p:sp>
-        <p:nvSpPr>
-          <p:cNvPr id="4" name="Slide Number Placeholder 3"/>
-          <p:cNvSpPr>
-            <a:spLocks noGrp="1"/>
-          </p:cNvSpPr>
-          <p:nvPr>
-            <p:ph type="sldNum" sz="quarter" idx="10"/>
-          </p:nvPr>
-        </p:nvSpPr>
-        <p:spPr/>
-        <p:txBody>
-          <a:bodyPr/>
-          <a:lstStyle/>
-          <a:p>
-            <a:fld id="{F7021451-1387-4CA6-816F-3879F97B5CBC}" type="slidenum">
-              <a:rPr lang="en-US"/>
-              <a:t>10</a:t>
-            </a:fld>
-            <a:endParaRPr lang="en-US"/>
-          </a:p>
-        </p:txBody>
-      </p:sp>
-    </p:spTree>
-    <p:extLst>
-      <p:ext uri="{BB962C8B-B14F-4D97-AF65-F5344CB8AC3E}">
-        <p14:creationId xmlns:p14="http://schemas.microsoft.com/office/powerpoint/2010/main" val="1024086991"/>
-      </p:ext>
-    </p:extLst>
-  </p:cSld>
-  <p:clrMapOvr>
-    <a:masterClrMapping/>
-  </p:clrMapOvr>
-</p:notes>
-</file>
-
 <file path=ppt/notesSlides/notesSlide2.xml><?xml version="1.0" encoding="utf-8"?>
 <p:notes xmlns:a="http://schemas.openxmlformats.org/drawingml/2006/main" xmlns:r="http://schemas.openxmlformats.org/officeDocument/2006/relationships" xmlns:p="http://schemas.openxmlformats.org/presentationml/2006/main">
   <p:cSld>
@@ -687,7 +598,7 @@
           <a:p>
             <a:r>
               <a:rPr lang="en-US" dirty="0"/>
-              <a:t>Six stops. The story is the skipped strip, then the Oracle flag read that turns it back on.</a:t>
+              <a:t>Five stops. Promotion and fallback sit on one slide: ship the library, or put the previous one back.</a:t>
             </a:r>
             <a:endParaRPr lang="en-US" dirty="0"/>
           </a:p>
@@ -1039,7 +950,7 @@
           <a:p>
             <a:r>
               <a:rPr lang="en-US" dirty="0"/>
-              <a:t>DEVQA, SIT, and PROD keep the same JDBC settings. What changes is the library binary.</a:t>
+              <a:t>DEVQA, SIT, and PROD keep the same JDBC settings. What changes is the library binary. You know the rollback worked when the old warning is back. A wrong saved answer is cleared with DELETE /api/clearCachedDBConn/{hospital}/{lab}.</a:t>
             </a:r>
             <a:endParaRPr lang="en-US" dirty="0"/>
           </a:p>
@@ -1127,7 +1038,7 @@
           <a:p>
             <a:r>
               <a:rPr lang="en-US" dirty="0"/>
-              <a:t>You know the rollback worked when the old warning is back: defaulting to PostgreSQL.</a:t>
+              <a:t>The first question is whether a second Oracle database is registered. The second is enlistment only. We are not redesigning transaction locking.</a:t>
             </a:r>
             <a:endParaRPr lang="en-US" dirty="0"/>
           </a:p>
@@ -1215,7 +1126,7 @@
           <a:p>
             <a:r>
               <a:rPr lang="en-US" dirty="0"/>
-              <a:t>The first question is whether a second Oracle database is registered. The second is enlistment only. We are not redesigning transaction locking.</a:t>
+              <a:t>Likely question: does patient sync source change? No. The strip is already there. It runs again once the Oracle flag can be read.</a:t>
             </a:r>
             <a:endParaRPr lang="en-US" dirty="0"/>
           </a:p>
@@ -1303,7 +1214,7 @@
           <a:p>
             <a:r>
               <a:rPr lang="en-US" dirty="0"/>
-              <a:t>Likely question: does patient sync source change? No. The strip is already there. It runs again once the Oracle flag can be read.</a:t>
+              <a:t>After the room, write any CP3 actions back onto the design note. This deck does not close the review gate.</a:t>
             </a:r>
             <a:endParaRPr lang="en-US" dirty="0"/>
           </a:p>
@@ -2453,423 +2364,6 @@
 </p:sld>
 </file>
 
-<file path=ppt/slides/slide10.xml><?xml version="1.0" encoding="utf-8"?>
-<p:sld xmlns:a="http://schemas.openxmlformats.org/drawingml/2006/main" xmlns:r="http://schemas.openxmlformats.org/officeDocument/2006/relationships" xmlns:p="http://schemas.openxmlformats.org/presentationml/2006/main">
-  <p:cSld name="Slide 10">
-    <p:bg>
-      <p:bgPr>
-        <a:solidFill>
-          <a:srgbClr val="090D16"/>
-        </a:solidFill>
-      </p:bgPr>
-    </p:bg>
-    <p:spTree>
-      <p:nvGrpSpPr>
-        <p:cNvPr id="1" name=""/>
-        <p:cNvGrpSpPr/>
-        <p:nvPr/>
-      </p:nvGrpSpPr>
-      <p:grpSpPr>
-        <a:xfrm>
-          <a:off x="0" y="0"/>
-          <a:ext cx="0" cy="0"/>
-          <a:chOff x="0" y="0"/>
-          <a:chExt cx="0" cy="0"/>
-        </a:xfrm>
-      </p:grpSpPr>
-      <p:sp>
-        <p:nvSpPr>
-          <p:cNvPr id="2" name="Shape 0"/>
-          <p:cNvSpPr/>
-          <p:nvPr/>
-        </p:nvSpPr>
-        <p:spPr>
-          <a:xfrm>
-            <a:off x="5867400" y="2052161"/>
-            <a:ext cx="457200" cy="457200"/>
-          </a:xfrm>
-          <a:prstGeom prst="ellipse">
-            <a:avLst/>
-          </a:prstGeom>
-          <a:solidFill>
-            <a:srgbClr val="082F49"/>
-          </a:solidFill>
-          <a:ln w="12700">
-            <a:solidFill>
-              <a:srgbClr val="082F49"/>
-            </a:solidFill>
-            <a:prstDash val="solid"/>
-          </a:ln>
-        </p:spPr>
-      </p:sp>
-      <p:pic>
-        <p:nvPicPr>
-          <p:cNvPr id="3" name="Image 0" descr="D:\Github\HA-Notes\LIS\skills\design-review-pptx\assets\icons\png\onDark\clipboard-check.png">    </p:cNvPr>
-          <p:cNvPicPr>
-            <a:picLocks noChangeAspect="1"/>
-          </p:cNvPicPr>
-          <p:nvPr/>
-        </p:nvPicPr>
-        <p:blipFill>
-          <a:blip r:embed="rId1"/>
-          <a:stretch>
-            <a:fillRect/>
-          </a:stretch>
-        </p:blipFill>
-        <p:spPr>
-          <a:xfrm>
-            <a:off x="5981700" y="2166461"/>
-            <a:ext cx="228600" cy="228600"/>
-          </a:xfrm>
-          <a:prstGeom prst="rect">
-            <a:avLst/>
-          </a:prstGeom>
-        </p:spPr>
-      </p:pic>
-      <p:sp>
-        <p:nvSpPr>
-          <p:cNvPr id="4" name="Text 1"/>
-          <p:cNvSpPr/>
-          <p:nvPr/>
-        </p:nvSpPr>
-        <p:spPr>
-          <a:xfrm>
-            <a:off x="1752600" y="2701385"/>
-            <a:ext cx="8686800" cy="481965"/>
-          </a:xfrm>
-          <a:prstGeom prst="rect">
-            <a:avLst/>
-          </a:prstGeom>
-          <a:noFill/>
-          <a:ln/>
-        </p:spPr>
-        <p:txBody>
-          <a:bodyPr wrap="square" lIns="0" tIns="0" rIns="0" bIns="0" rtlCol="0" anchor="t"/>
-          <a:lstStyle/>
-          <a:p>
-            <a:pPr algn="ctr" indent="0" marL="0">
-              <a:lnSpc>
-                <a:spcPct val="105000"/>
-              </a:lnSpc>
-              <a:buNone/>
-            </a:pPr>
-            <a:r>
-              <a:rPr lang="en-US" sz="3300" dirty="0">
-                <a:solidFill>
-                  <a:srgbClr val="FFFFFF"/>
-                </a:solidFill>
-                <a:latin typeface="Segoe UI Semibold" pitchFamily="34" charset="0"/>
-                <a:ea typeface="Segoe UI Semibold" pitchFamily="34" charset="-122"/>
-                <a:cs typeface="Segoe UI Semibold" pitchFamily="34" charset="-120"/>
-              </a:rPr>
-              <a:t>Read the flag, then strip for Sybase</a:t>
-            </a:r>
-            <a:endParaRPr lang="en-US" sz="3300" dirty="0"/>
-          </a:p>
-        </p:txBody>
-      </p:sp>
-      <p:sp>
-        <p:nvSpPr>
-          <p:cNvPr id="5" name="Text 2"/>
-          <p:cNvSpPr/>
-          <p:nvPr/>
-        </p:nvSpPr>
-        <p:spPr>
-          <a:xfrm>
-            <a:off x="2406396" y="3338798"/>
-            <a:ext cx="7379208" cy="214313"/>
-          </a:xfrm>
-          <a:prstGeom prst="rect">
-            <a:avLst/>
-          </a:prstGeom>
-          <a:noFill/>
-          <a:ln/>
-        </p:spPr>
-        <p:txBody>
-          <a:bodyPr wrap="square" lIns="0" tIns="0" rIns="0" bIns="0" rtlCol="0" anchor="t"/>
-          <a:lstStyle/>
-          <a:p>
-            <a:pPr algn="ctr" indent="0" marL="0">
-              <a:lnSpc>
-                <a:spcPct val="120000"/>
-              </a:lnSpc>
-              <a:buNone/>
-            </a:pPr>
-            <a:r>
-              <a:rPr lang="en-US" sz="1350" dirty="0">
-                <a:solidFill>
-                  <a:srgbClr val="94A3B8"/>
-                </a:solidFill>
-                <a:latin typeface="Segoe UI" pitchFamily="34" charset="0"/>
-                <a:ea typeface="Segoe UI" pitchFamily="34" charset="-122"/>
-                <a:cs typeface="Segoe UI" pitchFamily="34" charset="-120"/>
-              </a:rPr>
-              <a:t>No schema change. No config change.</a:t>
-            </a:r>
-            <a:endParaRPr lang="en-US" sz="1350" dirty="0"/>
-          </a:p>
-        </p:txBody>
-      </p:sp>
-      <p:sp>
-        <p:nvSpPr>
-          <p:cNvPr id="6" name="Text 3"/>
-          <p:cNvSpPr/>
-          <p:nvPr/>
-        </p:nvSpPr>
-        <p:spPr>
-          <a:xfrm>
-            <a:off x="2548128" y="3937159"/>
-            <a:ext cx="3291840" cy="182880"/>
-          </a:xfrm>
-          <a:prstGeom prst="rect">
-            <a:avLst/>
-          </a:prstGeom>
-          <a:noFill/>
-          <a:ln/>
-        </p:spPr>
-        <p:txBody>
-          <a:bodyPr wrap="square" lIns="0" tIns="0" rIns="0" bIns="0" rtlCol="0" anchor="t"/>
-          <a:lstStyle/>
-          <a:p>
-            <a:pPr algn="l" indent="0" marL="0">
-              <a:lnSpc>
-                <a:spcPct val="115000"/>
-              </a:lnSpc>
-              <a:buNone/>
-            </a:pPr>
-            <a:r>
-              <a:rPr lang="en-US" sz="1050" dirty="0">
-                <a:solidFill>
-                  <a:srgbClr val="64748B"/>
-                </a:solidFill>
-                <a:latin typeface="Segoe UI" pitchFamily="34" charset="0"/>
-                <a:ea typeface="Segoe UI" pitchFamily="34" charset="-122"/>
-                <a:cs typeface="Segoe UI" pitchFamily="34" charset="-120"/>
-              </a:rPr>
-              <a:t>AFTER CP3</a:t>
-            </a:r>
-            <a:endParaRPr lang="en-US" sz="1050" dirty="0"/>
-          </a:p>
-        </p:txBody>
-      </p:sp>
-      <p:sp>
-        <p:nvSpPr>
-          <p:cNvPr id="7" name="Text 4"/>
-          <p:cNvSpPr/>
-          <p:nvPr/>
-        </p:nvSpPr>
-        <p:spPr>
-          <a:xfrm>
-            <a:off x="2548128" y="4156615"/>
-            <a:ext cx="3291840" cy="640080"/>
-          </a:xfrm>
-          <a:prstGeom prst="rect">
-            <a:avLst/>
-          </a:prstGeom>
-          <a:noFill/>
-          <a:ln/>
-        </p:spPr>
-        <p:txBody>
-          <a:bodyPr wrap="square" lIns="0" tIns="0" rIns="0" bIns="0" rtlCol="0" anchor="t"/>
-          <a:lstStyle/>
-          <a:p>
-            <a:pPr algn="l" indent="0" marL="0">
-              <a:lnSpc>
-                <a:spcPct val="115000"/>
-              </a:lnSpc>
-              <a:buNone/>
-            </a:pPr>
-            <a:r>
-              <a:rPr lang="en-US" sz="1200" dirty="0">
-                <a:solidFill>
-                  <a:srgbClr val="F1F5F9"/>
-                </a:solidFill>
-                <a:latin typeface="Segoe UI" pitchFamily="34" charset="0"/>
-                <a:ea typeface="Segoe UI" pitchFamily="34" charset="-122"/>
-                <a:cs typeface="Segoe UI" pitchFamily="34" charset="-120"/>
-              </a:rPr>
-              <a:t>Write actions back onto the design note</a:t>
-            </a:r>
-            <a:endParaRPr lang="en-US" sz="1200" dirty="0"/>
-          </a:p>
-        </p:txBody>
-      </p:sp>
-      <p:sp>
-        <p:nvSpPr>
-          <p:cNvPr id="8" name="Shape 5"/>
-          <p:cNvSpPr/>
-          <p:nvPr/>
-        </p:nvSpPr>
-        <p:spPr>
-          <a:xfrm>
-            <a:off x="6096000" y="3937159"/>
-            <a:ext cx="10973" cy="566928"/>
-          </a:xfrm>
-          <a:prstGeom prst="rect">
-            <a:avLst/>
-          </a:prstGeom>
-          <a:solidFill>
-            <a:srgbClr val="1E293B"/>
-          </a:solidFill>
-          <a:ln w="12700">
-            <a:solidFill>
-              <a:srgbClr val="1E293B"/>
-            </a:solidFill>
-            <a:prstDash val="solid"/>
-          </a:ln>
-        </p:spPr>
-      </p:sp>
-      <p:sp>
-        <p:nvSpPr>
-          <p:cNvPr id="9" name="Text 6"/>
-          <p:cNvSpPr/>
-          <p:nvPr/>
-        </p:nvSpPr>
-        <p:spPr>
-          <a:xfrm>
-            <a:off x="6352032" y="3937159"/>
-            <a:ext cx="3291840" cy="182880"/>
-          </a:xfrm>
-          <a:prstGeom prst="rect">
-            <a:avLst/>
-          </a:prstGeom>
-          <a:noFill/>
-          <a:ln/>
-        </p:spPr>
-        <p:txBody>
-          <a:bodyPr wrap="square" lIns="0" tIns="0" rIns="0" bIns="0" rtlCol="0" anchor="t"/>
-          <a:lstStyle/>
-          <a:p>
-            <a:pPr algn="l" indent="0" marL="0">
-              <a:lnSpc>
-                <a:spcPct val="115000"/>
-              </a:lnSpc>
-              <a:buNone/>
-            </a:pPr>
-            <a:r>
-              <a:rPr lang="en-US" sz="1050" dirty="0">
-                <a:solidFill>
-                  <a:srgbClr val="64748B"/>
-                </a:solidFill>
-                <a:latin typeface="Segoe UI" pitchFamily="34" charset="0"/>
-                <a:ea typeface="Segoe UI" pitchFamily="34" charset="-122"/>
-                <a:cs typeface="Segoe UI" pitchFamily="34" charset="-120"/>
-              </a:rPr>
-              <a:t>THEN BUILD</a:t>
-            </a:r>
-            <a:endParaRPr lang="en-US" sz="1050" dirty="0"/>
-          </a:p>
-        </p:txBody>
-      </p:sp>
-      <p:sp>
-        <p:nvSpPr>
-          <p:cNvPr id="10" name="Text 7"/>
-          <p:cNvSpPr/>
-          <p:nvPr/>
-        </p:nvSpPr>
-        <p:spPr>
-          <a:xfrm>
-            <a:off x="6352032" y="4156615"/>
-            <a:ext cx="3291840" cy="640080"/>
-          </a:xfrm>
-          <a:prstGeom prst="rect">
-            <a:avLst/>
-          </a:prstGeom>
-          <a:noFill/>
-          <a:ln/>
-        </p:spPr>
-        <p:txBody>
-          <a:bodyPr wrap="square" lIns="0" tIns="0" rIns="0" bIns="0" rtlCol="0" anchor="t"/>
-          <a:lstStyle/>
-          <a:p>
-            <a:pPr algn="l" indent="0" marL="0">
-              <a:lnSpc>
-                <a:spcPct val="115000"/>
-              </a:lnSpc>
-              <a:buNone/>
-            </a:pPr>
-            <a:r>
-              <a:rPr lang="en-US" sz="1200" dirty="0">
-                <a:solidFill>
-                  <a:srgbClr val="F1F5F9"/>
-                </a:solidFill>
-                <a:latin typeface="Segoe UI" pitchFamily="34" charset="0"/>
-                <a:ea typeface="Segoe UI" pitchFamily="34" charset="-122"/>
-                <a:cs typeface="Segoe UI" pitchFamily="34" charset="-120"/>
-              </a:rPr>
-              <a:t>data-source only</a:t>
-            </a:r>
-            <a:endParaRPr lang="en-US" sz="1200" dirty="0"/>
-          </a:p>
-        </p:txBody>
-      </p:sp>
-      <p:sp>
-        <p:nvSpPr>
-          <p:cNvPr id="11" name="Text 8"/>
-          <p:cNvSpPr/>
-          <p:nvPr/>
-        </p:nvSpPr>
-        <p:spPr>
-          <a:xfrm>
-            <a:off x="758952" y="6089904"/>
-            <a:ext cx="10674096" cy="237744"/>
-          </a:xfrm>
-          <a:prstGeom prst="rect">
-            <a:avLst/>
-          </a:prstGeom>
-          <a:noFill/>
-          <a:ln/>
-        </p:spPr>
-        <p:txBody>
-          <a:bodyPr wrap="square" lIns="0" tIns="0" rIns="0" bIns="0" rtlCol="0" anchor="t"/>
-          <a:lstStyle/>
-          <a:p>
-            <a:pPr algn="ctr" indent="0" marL="0">
-              <a:lnSpc>
-                <a:spcPct val="120000"/>
-              </a:lnSpc>
-              <a:buNone/>
-            </a:pPr>
-            <a:r>
-              <a:rPr lang="en-US" sz="1125" dirty="0">
-                <a:solidFill>
-                  <a:srgbClr val="38BDF8"/>
-                </a:solidFill>
-                <a:latin typeface="Consolas" pitchFamily="34" charset="0"/>
-                <a:ea typeface="Consolas" pitchFamily="34" charset="-122"/>
-                <a:cs typeface="Consolas" pitchFamily="34" charset="-120"/>
-              </a:rPr>
-              <a:t>TMP-oracle-route-lookup   </a:t>
-            </a:r>
-            <a:pPr algn="ctr" indent="0" marL="0">
-              <a:lnSpc>
-                <a:spcPct val="120000"/>
-              </a:lnSpc>
-              <a:buNone/>
-            </a:pPr>
-            <a:r>
-              <a:rPr lang="en-US" sz="1125" dirty="0">
-                <a:solidFill>
-                  <a:srgbClr val="64748B"/>
-                </a:solidFill>
-                <a:latin typeface="Segoe UI" pitchFamily="34" charset="0"/>
-                <a:ea typeface="Segoe UI" pitchFamily="34" charset="-122"/>
-                <a:cs typeface="Segoe UI" pitchFamily="34" charset="-120"/>
-              </a:rPr>
-              <a:t>lis-patient-pmi-sync-svc  ·  LIS-10723</a:t>
-            </a:r>
-            <a:endParaRPr lang="en-US" sz="1125" dirty="0"/>
-          </a:p>
-        </p:txBody>
-      </p:sp>
-    </p:spTree>
-  </p:cSld>
-  <p:clrMapOvr>
-    <a:masterClrMapping/>
-  </p:clrMapOvr>
-</p:sld>
-</file>
-
 <file path=ppt/slides/slide2.xml><?xml version="1.0" encoding="utf-8"?>
 <p:sld xmlns:a="http://schemas.openxmlformats.org/drawingml/2006/main" xmlns:r="http://schemas.openxmlformats.org/officeDocument/2006/relationships" xmlns:p="http://schemas.openxmlformats.org/presentationml/2006/main">
   <p:cSld name="Slide 2">
@@ -2966,7 +2460,7 @@
                 <a:ea typeface="Segoe UI Semibold" pitchFamily="34" charset="-122"/>
                 <a:cs typeface="Segoe UI Semibold" pitchFamily="34" charset="-120"/>
               </a:rPr>
-              <a:t>Six stops</a:t>
+              <a:t>Five stops</a:t>
             </a:r>
             <a:endParaRPr lang="en-US" sz="2400" dirty="0"/>
           </a:p>
@@ -2980,12 +2474,12 @@
         </p:nvSpPr>
         <p:spPr>
           <a:xfrm>
-            <a:off x="609600" y="1371600"/>
-            <a:ext cx="10972800" cy="716280"/>
+            <a:off x="609600" y="1581912"/>
+            <a:ext cx="10972800" cy="804672"/>
           </a:xfrm>
           <a:prstGeom prst="roundRect">
             <a:avLst>
-              <a:gd name="adj" fmla="val 15319"/>
+              <a:gd name="adj" fmla="val 13636"/>
             </a:avLst>
           </a:prstGeom>
           <a:solidFill>
@@ -3007,8 +2501,8 @@
         </p:nvSpPr>
         <p:spPr>
           <a:xfrm>
-            <a:off x="847344" y="1371600"/>
-            <a:ext cx="502920" cy="716280"/>
+            <a:off x="847344" y="1581912"/>
+            <a:ext cx="502920" cy="804672"/>
           </a:xfrm>
           <a:prstGeom prst="rect">
             <a:avLst/>
@@ -3049,7 +2543,7 @@
         </p:nvSpPr>
         <p:spPr>
           <a:xfrm>
-            <a:off x="1341120" y="1473708"/>
+            <a:off x="1341120" y="1728216"/>
             <a:ext cx="10003536" cy="246888"/>
           </a:xfrm>
           <a:prstGeom prst="rect">
@@ -3091,7 +2585,7 @@
         </p:nvSpPr>
         <p:spPr>
           <a:xfrm>
-            <a:off x="1341120" y="1738884"/>
+            <a:off x="1341120" y="1993392"/>
             <a:ext cx="10003536" cy="219456"/>
           </a:xfrm>
           <a:prstGeom prst="rect">
@@ -3133,12 +2627,12 @@
         </p:nvSpPr>
         <p:spPr>
           <a:xfrm>
-            <a:off x="609600" y="2234184"/>
-            <a:ext cx="10972800" cy="716280"/>
+            <a:off x="609600" y="2532888"/>
+            <a:ext cx="10972800" cy="804672"/>
           </a:xfrm>
           <a:prstGeom prst="roundRect">
             <a:avLst>
-              <a:gd name="adj" fmla="val 15319"/>
+              <a:gd name="adj" fmla="val 13636"/>
             </a:avLst>
           </a:prstGeom>
           <a:solidFill>
@@ -3160,8 +2654,8 @@
         </p:nvSpPr>
         <p:spPr>
           <a:xfrm>
-            <a:off x="847344" y="2234184"/>
-            <a:ext cx="502920" cy="716280"/>
+            <a:off x="847344" y="2532888"/>
+            <a:ext cx="502920" cy="804672"/>
           </a:xfrm>
           <a:prstGeom prst="rect">
             <a:avLst/>
@@ -3202,7 +2696,7 @@
         </p:nvSpPr>
         <p:spPr>
           <a:xfrm>
-            <a:off x="1341120" y="2336292"/>
+            <a:off x="1341120" y="2679192"/>
             <a:ext cx="10003536" cy="246888"/>
           </a:xfrm>
           <a:prstGeom prst="rect">
@@ -3244,7 +2738,7 @@
         </p:nvSpPr>
         <p:spPr>
           <a:xfrm>
-            <a:off x="1341120" y="2601468"/>
+            <a:off x="1341120" y="2944368"/>
             <a:ext cx="10003536" cy="219456"/>
           </a:xfrm>
           <a:prstGeom prst="rect">
@@ -3286,12 +2780,12 @@
         </p:nvSpPr>
         <p:spPr>
           <a:xfrm>
-            <a:off x="609600" y="3096768"/>
-            <a:ext cx="10972800" cy="716280"/>
+            <a:off x="609600" y="3483864"/>
+            <a:ext cx="10972800" cy="804672"/>
           </a:xfrm>
           <a:prstGeom prst="roundRect">
             <a:avLst>
-              <a:gd name="adj" fmla="val 15319"/>
+              <a:gd name="adj" fmla="val 13636"/>
             </a:avLst>
           </a:prstGeom>
           <a:solidFill>
@@ -3313,8 +2807,8 @@
         </p:nvSpPr>
         <p:spPr>
           <a:xfrm>
-            <a:off x="847344" y="3096768"/>
-            <a:ext cx="502920" cy="716280"/>
+            <a:off x="847344" y="3483864"/>
+            <a:ext cx="502920" cy="804672"/>
           </a:xfrm>
           <a:prstGeom prst="rect">
             <a:avLst/>
@@ -3355,7 +2849,7 @@
         </p:nvSpPr>
         <p:spPr>
           <a:xfrm>
-            <a:off x="1341120" y="3198876"/>
+            <a:off x="1341120" y="3630168"/>
             <a:ext cx="10003536" cy="246888"/>
           </a:xfrm>
           <a:prstGeom prst="rect">
@@ -3397,7 +2891,7 @@
         </p:nvSpPr>
         <p:spPr>
           <a:xfrm>
-            <a:off x="1341120" y="3464052"/>
+            <a:off x="1341120" y="3895344"/>
             <a:ext cx="10003536" cy="219456"/>
           </a:xfrm>
           <a:prstGeom prst="rect">
@@ -3439,12 +2933,12 @@
         </p:nvSpPr>
         <p:spPr>
           <a:xfrm>
-            <a:off x="609600" y="3959352"/>
-            <a:ext cx="10972800" cy="716280"/>
+            <a:off x="609600" y="4434840"/>
+            <a:ext cx="10972800" cy="804672"/>
           </a:xfrm>
           <a:prstGeom prst="roundRect">
             <a:avLst>
-              <a:gd name="adj" fmla="val 15319"/>
+              <a:gd name="adj" fmla="val 13636"/>
             </a:avLst>
           </a:prstGeom>
           <a:solidFill>
@@ -3466,8 +2960,8 @@
         </p:nvSpPr>
         <p:spPr>
           <a:xfrm>
-            <a:off x="847344" y="3959352"/>
-            <a:ext cx="502920" cy="716280"/>
+            <a:off x="847344" y="4434840"/>
+            <a:ext cx="502920" cy="804672"/>
           </a:xfrm>
           <a:prstGeom prst="rect">
             <a:avLst/>
@@ -3508,7 +3002,7 @@
         </p:nvSpPr>
         <p:spPr>
           <a:xfrm>
-            <a:off x="1341120" y="4061460"/>
+            <a:off x="1341120" y="4581144"/>
             <a:ext cx="10003536" cy="246888"/>
           </a:xfrm>
           <a:prstGeom prst="rect">
@@ -3536,7 +3030,7 @@
                 <a:ea typeface="Segoe UI" pitchFamily="34" charset="-122"/>
                 <a:cs typeface="Segoe UI" pitchFamily="34" charset="-120"/>
               </a:rPr>
-              <a:t>Promotion</a:t>
+              <a:t>Promotion and fallback</a:t>
             </a:r>
             <a:endParaRPr lang="en-US" sz="1350" dirty="0"/>
           </a:p>
@@ -3550,7 +3044,7 @@
         </p:nvSpPr>
         <p:spPr>
           <a:xfrm>
-            <a:off x="1341120" y="4326636"/>
+            <a:off x="1341120" y="4846320"/>
             <a:ext cx="10003536" cy="219456"/>
           </a:xfrm>
           <a:prstGeom prst="rect">
@@ -3578,7 +3072,7 @@
                 <a:ea typeface="Segoe UI" pitchFamily="34" charset="-122"/>
                 <a:cs typeface="Segoe UI" pitchFamily="34" charset="-120"/>
               </a:rPr>
-              <a:t>library build, config unchanged</a:t>
+              <a:t>new library, or the previous one</a:t>
             </a:r>
             <a:endParaRPr lang="en-US" sz="1125" dirty="0"/>
           </a:p>
@@ -3592,12 +3086,12 @@
         </p:nvSpPr>
         <p:spPr>
           <a:xfrm>
-            <a:off x="609600" y="4821936"/>
-            <a:ext cx="10972800" cy="716280"/>
+            <a:off x="609600" y="5385816"/>
+            <a:ext cx="10972800" cy="804672"/>
           </a:xfrm>
           <a:prstGeom prst="roundRect">
             <a:avLst>
-              <a:gd name="adj" fmla="val 15319"/>
+              <a:gd name="adj" fmla="val 13636"/>
             </a:avLst>
           </a:prstGeom>
           <a:solidFill>
@@ -3619,8 +3113,8 @@
         </p:nvSpPr>
         <p:spPr>
           <a:xfrm>
-            <a:off x="847344" y="4821936"/>
-            <a:ext cx="502920" cy="716280"/>
+            <a:off x="847344" y="5385816"/>
+            <a:ext cx="502920" cy="804672"/>
           </a:xfrm>
           <a:prstGeom prst="rect">
             <a:avLst/>
@@ -3661,7 +3155,7 @@
         </p:nvSpPr>
         <p:spPr>
           <a:xfrm>
-            <a:off x="1341120" y="4924044"/>
+            <a:off x="1341120" y="5532120"/>
             <a:ext cx="10003536" cy="246888"/>
           </a:xfrm>
           <a:prstGeom prst="rect">
@@ -3689,7 +3183,7 @@
                 <a:ea typeface="Segoe UI" pitchFamily="34" charset="-122"/>
                 <a:cs typeface="Segoe UI" pitchFamily="34" charset="-120"/>
               </a:rPr>
-              <a:t>Fallback</a:t>
+              <a:t>Open Questions</a:t>
             </a:r>
             <a:endParaRPr lang="en-US" sz="1350" dirty="0"/>
           </a:p>
@@ -3703,160 +3197,7 @@
         </p:nvSpPr>
         <p:spPr>
           <a:xfrm>
-            <a:off x="1341120" y="5189220"/>
-            <a:ext cx="10003536" cy="219456"/>
-          </a:xfrm>
-          <a:prstGeom prst="rect">
-            <a:avLst/>
-          </a:prstGeom>
-          <a:noFill/>
-          <a:ln/>
-        </p:spPr>
-        <p:txBody>
-          <a:bodyPr wrap="square" lIns="0" tIns="0" rIns="0" bIns="0" rtlCol="0" anchor="ctr"/>
-          <a:lstStyle/>
-          <a:p>
-            <a:pPr algn="l" indent="0" marL="0">
-              <a:lnSpc>
-                <a:spcPct val="115000"/>
-              </a:lnSpc>
-              <a:buNone/>
-            </a:pPr>
-            <a:r>
-              <a:rPr lang="en-US" sz="1125" dirty="0">
-                <a:solidFill>
-                  <a:srgbClr val="64748B"/>
-                </a:solidFill>
-                <a:latin typeface="Segoe UI" pitchFamily="34" charset="0"/>
-                <a:ea typeface="Segoe UI" pitchFamily="34" charset="-122"/>
-                <a:cs typeface="Segoe UI" pitchFamily="34" charset="-120"/>
-              </a:rPr>
-              <a:t>previous library</a:t>
-            </a:r>
-            <a:endParaRPr lang="en-US" sz="1125" dirty="0"/>
-          </a:p>
-        </p:txBody>
-      </p:sp>
-      <p:sp>
-        <p:nvSpPr>
-          <p:cNvPr id="24" name="Shape 22"/>
-          <p:cNvSpPr/>
-          <p:nvPr/>
-        </p:nvSpPr>
-        <p:spPr>
-          <a:xfrm>
-            <a:off x="609600" y="5684520"/>
-            <a:ext cx="10972800" cy="716280"/>
-          </a:xfrm>
-          <a:prstGeom prst="roundRect">
-            <a:avLst>
-              <a:gd name="adj" fmla="val 15319"/>
-            </a:avLst>
-          </a:prstGeom>
-          <a:solidFill>
-            <a:srgbClr val="FFFFFF"/>
-          </a:solidFill>
-          <a:ln w="9525">
-            <a:solidFill>
-              <a:srgbClr val="E2E8F0"/>
-            </a:solidFill>
-            <a:prstDash val="solid"/>
-          </a:ln>
-        </p:spPr>
-      </p:sp>
-      <p:sp>
-        <p:nvSpPr>
-          <p:cNvPr id="25" name="Text 23"/>
-          <p:cNvSpPr/>
-          <p:nvPr/>
-        </p:nvSpPr>
-        <p:spPr>
-          <a:xfrm>
-            <a:off x="847344" y="5684520"/>
-            <a:ext cx="502920" cy="716280"/>
-          </a:xfrm>
-          <a:prstGeom prst="rect">
-            <a:avLst/>
-          </a:prstGeom>
-          <a:noFill/>
-          <a:ln/>
-        </p:spPr>
-        <p:txBody>
-          <a:bodyPr wrap="square" lIns="0" tIns="0" rIns="0" bIns="0" rtlCol="0" anchor="ctr"/>
-          <a:lstStyle/>
-          <a:p>
-            <a:pPr algn="l" indent="0" marL="0">
-              <a:lnSpc>
-                <a:spcPct val="115000"/>
-              </a:lnSpc>
-              <a:buNone/>
-            </a:pPr>
-            <a:r>
-              <a:rPr lang="en-US" sz="1500" dirty="0">
-                <a:solidFill>
-                  <a:srgbClr val="0284C7"/>
-                </a:solidFill>
-                <a:latin typeface="Segoe UI Semibold" pitchFamily="34" charset="0"/>
-                <a:ea typeface="Segoe UI Semibold" pitchFamily="34" charset="-122"/>
-                <a:cs typeface="Segoe UI Semibold" pitchFamily="34" charset="-120"/>
-              </a:rPr>
-              <a:t>06</a:t>
-            </a:r>
-            <a:endParaRPr lang="en-US" sz="1500" dirty="0"/>
-          </a:p>
-        </p:txBody>
-      </p:sp>
-      <p:sp>
-        <p:nvSpPr>
-          <p:cNvPr id="26" name="Text 24"/>
-          <p:cNvSpPr/>
-          <p:nvPr/>
-        </p:nvSpPr>
-        <p:spPr>
-          <a:xfrm>
-            <a:off x="1341120" y="5786628"/>
-            <a:ext cx="10003536" cy="246888"/>
-          </a:xfrm>
-          <a:prstGeom prst="rect">
-            <a:avLst/>
-          </a:prstGeom>
-          <a:noFill/>
-          <a:ln/>
-        </p:spPr>
-        <p:txBody>
-          <a:bodyPr wrap="square" lIns="0" tIns="0" rIns="0" bIns="0" rtlCol="0" anchor="ctr"/>
-          <a:lstStyle/>
-          <a:p>
-            <a:pPr algn="l" indent="0" marL="0">
-              <a:lnSpc>
-                <a:spcPct val="115000"/>
-              </a:lnSpc>
-              <a:buNone/>
-            </a:pPr>
-            <a:r>
-              <a:rPr lang="en-US" sz="1350" b="1" dirty="0">
-                <a:solidFill>
-                  <a:srgbClr val="0F172A"/>
-                </a:solidFill>
-                <a:latin typeface="Segoe UI" pitchFamily="34" charset="0"/>
-                <a:ea typeface="Segoe UI" pitchFamily="34" charset="-122"/>
-                <a:cs typeface="Segoe UI" pitchFamily="34" charset="-120"/>
-              </a:rPr>
-              <a:t>Open Questions</a:t>
-            </a:r>
-            <a:endParaRPr lang="en-US" sz="1350" dirty="0"/>
-          </a:p>
-        </p:txBody>
-      </p:sp>
-      <p:sp>
-        <p:nvSpPr>
-          <p:cNvPr id="27" name="Text 25"/>
-          <p:cNvSpPr/>
-          <p:nvPr/>
-        </p:nvSpPr>
-        <p:spPr>
-          <a:xfrm>
-            <a:off x="1341120" y="6051804"/>
+            <a:off x="1341120" y="5797296"/>
             <a:ext cx="10003536" cy="219456"/>
           </a:xfrm>
           <a:prstGeom prst="rect">
@@ -5953,7 +5294,7 @@
                 <a:ea typeface="Segoe UI Semibold" pitchFamily="34" charset="-122"/>
                 <a:cs typeface="Segoe UI Semibold" pitchFamily="34" charset="-120"/>
               </a:rPr>
-              <a:t>PROMOTION</a:t>
+              <a:t>PROMOTION AND FALLBACK</a:t>
             </a:r>
             <a:endParaRPr lang="en-US" sz="1050" dirty="0"/>
           </a:p>
@@ -5992,7 +5333,7 @@
                 <a:ea typeface="Segoe UI Semibold" pitchFamily="34" charset="-122"/>
                 <a:cs typeface="Segoe UI Semibold" pitchFamily="34" charset="-120"/>
               </a:rPr>
-              <a:t>Ship the library and leave config alone</a:t>
+              <a:t>Ship the new library, or put the previous one back</a:t>
             </a:r>
             <a:endParaRPr lang="en-US" sz="2400" dirty="0"/>
           </a:p>
@@ -6006,12 +5347,12 @@
         </p:nvSpPr>
         <p:spPr>
           <a:xfrm>
-            <a:off x="609600" y="2860834"/>
-            <a:ext cx="3505200" cy="2050732"/>
+            <a:off x="609600" y="2783777"/>
+            <a:ext cx="5335524" cy="2204847"/>
           </a:xfrm>
           <a:prstGeom prst="roundRect">
             <a:avLst>
-              <a:gd name="adj" fmla="val 5351"/>
+              <a:gd name="adj" fmla="val 4977"/>
             </a:avLst>
           </a:prstGeom>
           <a:solidFill>
@@ -6027,7 +5368,7 @@
       </p:sp>
       <p:pic>
         <p:nvPicPr>
-          <p:cNvPr id="5" name="Image 0" descr="D:\Github\HA-Notes\LIS\skills\design-review-pptx\assets\icons\png\accent\cloud-arrow-up.png">    </p:cNvPr>
+          <p:cNvPr id="5" name="Image 0" descr="D:\Github\HA-Notes\LIS\skills\design-review-pptx\assets\icons\png\success\cloud-arrow-up.png">    </p:cNvPr>
           <p:cNvPicPr>
             <a:picLocks noChangeAspect="1"/>
           </p:cNvPicPr>
@@ -6041,7 +5382,7 @@
         </p:blipFill>
         <p:spPr>
           <a:xfrm>
-            <a:off x="883920" y="3180874"/>
+            <a:off x="883920" y="3090101"/>
             <a:ext cx="265176" cy="265176"/>
           </a:xfrm>
           <a:prstGeom prst="rect">
@@ -6057,22 +5398,22 @@
         </p:nvSpPr>
         <p:spPr>
           <a:xfrm>
-            <a:off x="883920" y="3638074"/>
-            <a:ext cx="2956560" cy="219075"/>
-          </a:xfrm>
-          <a:prstGeom prst="rect">
-            <a:avLst/>
-          </a:prstGeom>
-          <a:noFill/>
-          <a:ln/>
-        </p:spPr>
-        <p:txBody>
-          <a:bodyPr wrap="square" lIns="0" tIns="0" rIns="0" bIns="0" rtlCol="0" anchor="t"/>
-          <a:lstStyle/>
-          <a:p>
-            <a:pPr algn="l" indent="0" marL="0">
-              <a:lnSpc>
-                <a:spcPct val="110000"/>
+            <a:off x="1249680" y="3076385"/>
+            <a:ext cx="4421124" cy="292608"/>
+          </a:xfrm>
+          <a:prstGeom prst="rect">
+            <a:avLst/>
+          </a:prstGeom>
+          <a:noFill/>
+          <a:ln/>
+        </p:spPr>
+        <p:txBody>
+          <a:bodyPr wrap="square" lIns="0" tIns="0" rIns="0" bIns="0" rtlCol="0" anchor="ctr"/>
+          <a:lstStyle/>
+          <a:p>
+            <a:pPr algn="l" indent="0" marL="0">
+              <a:lnSpc>
+                <a:spcPct val="115000"/>
               </a:lnSpc>
               <a:buNone/>
             </a:pPr>
@@ -6085,7 +5426,7 @@
                 <a:ea typeface="Segoe UI Semibold" pitchFamily="34" charset="-122"/>
                 <a:cs typeface="Segoe UI Semibold" pitchFamily="34" charset="-120"/>
               </a:rPr>
-              <a:t>New data-source build</a:t>
+              <a:t>Promotion</a:t>
             </a:r>
             <a:endParaRPr lang="en-US" sz="1500" dirty="0"/>
           </a:p>
@@ -6099,54 +5440,273 @@
         </p:nvSpPr>
         <p:spPr>
           <a:xfrm>
-            <a:off x="883920" y="3948589"/>
-            <a:ext cx="2956560" cy="798385"/>
-          </a:xfrm>
-          <a:prstGeom prst="rect">
-            <a:avLst/>
-          </a:prstGeom>
-          <a:noFill/>
-          <a:ln/>
-        </p:spPr>
-        <p:txBody>
-          <a:bodyPr wrap="square" lIns="0" tIns="0" rIns="0" bIns="0" rtlCol="0" anchor="t"/>
-          <a:lstStyle/>
-          <a:p>
-            <a:pPr algn="l" indent="0" marL="0">
-              <a:lnSpc>
-                <a:spcPct val="120000"/>
-              </a:lnSpc>
-              <a:buNone/>
-            </a:pPr>
-            <a:r>
-              <a:rPr lang="en-US" sz="1350" dirty="0">
-                <a:solidFill>
-                  <a:srgbClr val="475569"/>
+            <a:off x="883920" y="3506153"/>
+            <a:ext cx="228600" cy="228600"/>
+          </a:xfrm>
+          <a:prstGeom prst="ellipse">
+            <a:avLst/>
+          </a:prstGeom>
+          <a:solidFill>
+            <a:srgbClr val="DCFCE7"/>
+          </a:solidFill>
+          <a:ln>
+            <a:solidFill>
+              <a:srgbClr val="DCFCE7"/>
+            </a:solidFill>
+          </a:ln>
+        </p:spPr>
+        <p:txBody>
+          <a:bodyPr wrap="square" lIns="0" tIns="0" rIns="0" bIns="0" rtlCol="0" anchor="ctr"/>
+          <a:lstStyle/>
+          <a:p>
+            <a:pPr algn="ctr" indent="0" marL="0">
+              <a:buNone/>
+            </a:pPr>
+            <a:r>
+              <a:rPr lang="en-US" sz="975" b="1" dirty="0">
+                <a:solidFill>
+                  <a:srgbClr val="15803D"/>
                 </a:solidFill>
                 <a:latin typeface="Segoe UI" pitchFamily="34" charset="0"/>
                 <a:ea typeface="Segoe UI" pitchFamily="34" charset="-122"/>
                 <a:cs typeface="Segoe UI" pitchFamily="34" charset="-120"/>
               </a:rPr>
-              <a:t>Services take the fix by depending on the new library build.</a:t>
-            </a:r>
-            <a:endParaRPr lang="en-US" sz="1350" dirty="0"/>
-          </a:p>
-        </p:txBody>
-      </p:sp>
-      <p:sp>
-        <p:nvSpPr>
-          <p:cNvPr id="8" name="Shape 5"/>
-          <p:cNvSpPr/>
-          <p:nvPr/>
-        </p:nvSpPr>
-        <p:spPr>
-          <a:xfrm>
-            <a:off x="4343400" y="2860834"/>
-            <a:ext cx="3505200" cy="2050732"/>
+              <a:t>1</a:t>
+            </a:r>
+            <a:endParaRPr lang="en-US" sz="975" dirty="0"/>
+          </a:p>
+        </p:txBody>
+      </p:sp>
+      <p:sp>
+        <p:nvSpPr>
+          <p:cNvPr id="8" name="Text 5"/>
+          <p:cNvSpPr/>
+          <p:nvPr/>
+        </p:nvSpPr>
+        <p:spPr>
+          <a:xfrm>
+            <a:off x="1222248" y="3533585"/>
+            <a:ext cx="4448556" cy="196882"/>
+          </a:xfrm>
+          <a:prstGeom prst="rect">
+            <a:avLst/>
+          </a:prstGeom>
+          <a:noFill/>
+          <a:ln/>
+        </p:spPr>
+        <p:txBody>
+          <a:bodyPr wrap="square" lIns="0" tIns="0" rIns="0" bIns="0" rtlCol="0" anchor="t"/>
+          <a:lstStyle/>
+          <a:p>
+            <a:pPr algn="l" indent="0" marL="0">
+              <a:lnSpc>
+                <a:spcPct val="115000"/>
+              </a:lnSpc>
+              <a:buNone/>
+            </a:pPr>
+            <a:r>
+              <a:rPr lang="en-US" sz="1125" dirty="0">
+                <a:solidFill>
+                  <a:srgbClr val="334155"/>
+                </a:solidFill>
+                <a:latin typeface="Segoe UI" pitchFamily="34" charset="0"/>
+                <a:ea typeface="Segoe UI" pitchFamily="34" charset="-122"/>
+                <a:cs typeface="Segoe UI" pitchFamily="34" charset="-120"/>
+              </a:rPr>
+              <a:t>Ship a new data-source build</a:t>
+            </a:r>
+            <a:endParaRPr lang="en-US" sz="1125" dirty="0"/>
+          </a:p>
+        </p:txBody>
+      </p:sp>
+      <p:sp>
+        <p:nvSpPr>
+          <p:cNvPr id="9" name="Text 6"/>
+          <p:cNvSpPr/>
+          <p:nvPr/>
+        </p:nvSpPr>
+        <p:spPr>
+          <a:xfrm>
+            <a:off x="883920" y="3840194"/>
+            <a:ext cx="228600" cy="228600"/>
+          </a:xfrm>
+          <a:prstGeom prst="ellipse">
+            <a:avLst/>
+          </a:prstGeom>
+          <a:solidFill>
+            <a:srgbClr val="DCFCE7"/>
+          </a:solidFill>
+          <a:ln>
+            <a:solidFill>
+              <a:srgbClr val="DCFCE7"/>
+            </a:solidFill>
+          </a:ln>
+        </p:spPr>
+        <p:txBody>
+          <a:bodyPr wrap="square" lIns="0" tIns="0" rIns="0" bIns="0" rtlCol="0" anchor="ctr"/>
+          <a:lstStyle/>
+          <a:p>
+            <a:pPr algn="ctr" indent="0" marL="0">
+              <a:buNone/>
+            </a:pPr>
+            <a:r>
+              <a:rPr lang="en-US" sz="975" b="1" dirty="0">
+                <a:solidFill>
+                  <a:srgbClr val="15803D"/>
+                </a:solidFill>
+                <a:latin typeface="Segoe UI" pitchFamily="34" charset="0"/>
+                <a:ea typeface="Segoe UI" pitchFamily="34" charset="-122"/>
+                <a:cs typeface="Segoe UI" pitchFamily="34" charset="-120"/>
+              </a:rPr>
+              <a:t>2</a:t>
+            </a:r>
+            <a:endParaRPr lang="en-US" sz="975" dirty="0"/>
+          </a:p>
+        </p:txBody>
+      </p:sp>
+      <p:sp>
+        <p:nvSpPr>
+          <p:cNvPr id="10" name="Text 7"/>
+          <p:cNvSpPr/>
+          <p:nvPr/>
+        </p:nvSpPr>
+        <p:spPr>
+          <a:xfrm>
+            <a:off x="1222248" y="3867626"/>
+            <a:ext cx="4448556" cy="196882"/>
+          </a:xfrm>
+          <a:prstGeom prst="rect">
+            <a:avLst/>
+          </a:prstGeom>
+          <a:noFill/>
+          <a:ln/>
+        </p:spPr>
+        <p:txBody>
+          <a:bodyPr wrap="square" lIns="0" tIns="0" rIns="0" bIns="0" rtlCol="0" anchor="t"/>
+          <a:lstStyle/>
+          <a:p>
+            <a:pPr algn="l" indent="0" marL="0">
+              <a:lnSpc>
+                <a:spcPct val="115000"/>
+              </a:lnSpc>
+              <a:buNone/>
+            </a:pPr>
+            <a:r>
+              <a:rPr lang="en-US" sz="1125" dirty="0">
+                <a:solidFill>
+                  <a:srgbClr val="334155"/>
+                </a:solidFill>
+                <a:latin typeface="Segoe UI" pitchFamily="34" charset="0"/>
+                <a:ea typeface="Segoe UI" pitchFamily="34" charset="-122"/>
+                <a:cs typeface="Segoe UI" pitchFamily="34" charset="-120"/>
+              </a:rPr>
+              <a:t>Leave JDBC settings unchanged in DEVQA, SIT, and PROD</a:t>
+            </a:r>
+            <a:endParaRPr lang="en-US" sz="1125" dirty="0"/>
+          </a:p>
+        </p:txBody>
+      </p:sp>
+      <p:sp>
+        <p:nvSpPr>
+          <p:cNvPr id="11" name="Text 8"/>
+          <p:cNvSpPr/>
+          <p:nvPr/>
+        </p:nvSpPr>
+        <p:spPr>
+          <a:xfrm>
+            <a:off x="883920" y="4174236"/>
+            <a:ext cx="228600" cy="228600"/>
+          </a:xfrm>
+          <a:prstGeom prst="ellipse">
+            <a:avLst/>
+          </a:prstGeom>
+          <a:solidFill>
+            <a:srgbClr val="DCFCE7"/>
+          </a:solidFill>
+          <a:ln>
+            <a:solidFill>
+              <a:srgbClr val="DCFCE7"/>
+            </a:solidFill>
+          </a:ln>
+        </p:spPr>
+        <p:txBody>
+          <a:bodyPr wrap="square" lIns="0" tIns="0" rIns="0" bIns="0" rtlCol="0" anchor="ctr"/>
+          <a:lstStyle/>
+          <a:p>
+            <a:pPr algn="ctr" indent="0" marL="0">
+              <a:buNone/>
+            </a:pPr>
+            <a:r>
+              <a:rPr lang="en-US" sz="975" b="1" dirty="0">
+                <a:solidFill>
+                  <a:srgbClr val="15803D"/>
+                </a:solidFill>
+                <a:latin typeface="Segoe UI" pitchFamily="34" charset="0"/>
+                <a:ea typeface="Segoe UI" pitchFamily="34" charset="-122"/>
+                <a:cs typeface="Segoe UI" pitchFamily="34" charset="-120"/>
+              </a:rPr>
+              <a:t>3</a:t>
+            </a:r>
+            <a:endParaRPr lang="en-US" sz="975" dirty="0"/>
+          </a:p>
+        </p:txBody>
+      </p:sp>
+      <p:sp>
+        <p:nvSpPr>
+          <p:cNvPr id="12" name="Text 9"/>
+          <p:cNvSpPr/>
+          <p:nvPr/>
+        </p:nvSpPr>
+        <p:spPr>
+          <a:xfrm>
+            <a:off x="1222248" y="4201668"/>
+            <a:ext cx="4448556" cy="196882"/>
+          </a:xfrm>
+          <a:prstGeom prst="rect">
+            <a:avLst/>
+          </a:prstGeom>
+          <a:noFill/>
+          <a:ln/>
+        </p:spPr>
+        <p:txBody>
+          <a:bodyPr wrap="square" lIns="0" tIns="0" rIns="0" bIns="0" rtlCol="0" anchor="t"/>
+          <a:lstStyle/>
+          <a:p>
+            <a:pPr algn="l" indent="0" marL="0">
+              <a:lnSpc>
+                <a:spcPct val="115000"/>
+              </a:lnSpc>
+              <a:buNone/>
+            </a:pPr>
+            <a:r>
+              <a:rPr lang="en-US" sz="1125" dirty="0">
+                <a:solidFill>
+                  <a:srgbClr val="334155"/>
+                </a:solidFill>
+                <a:latin typeface="Segoe UI" pitchFamily="34" charset="0"/>
+                <a:ea typeface="Segoe UI" pitchFamily="34" charset="-122"/>
+                <a:cs typeface="Segoe UI" pitchFamily="34" charset="-120"/>
+              </a:rPr>
+              <a:t>Rebuild lis-patient-pmi-sync-svc. Its source stays the same</a:t>
+            </a:r>
+            <a:endParaRPr lang="en-US" sz="1125" dirty="0"/>
+          </a:p>
+        </p:txBody>
+      </p:sp>
+      <p:sp>
+        <p:nvSpPr>
+          <p:cNvPr id="13" name="Shape 10"/>
+          <p:cNvSpPr/>
+          <p:nvPr/>
+        </p:nvSpPr>
+        <p:spPr>
+          <a:xfrm>
+            <a:off x="6246876" y="2783777"/>
+            <a:ext cx="5335524" cy="2204847"/>
           </a:xfrm>
           <a:prstGeom prst="roundRect">
             <a:avLst>
-              <a:gd name="adj" fmla="val 5351"/>
+              <a:gd name="adj" fmla="val 4977"/>
             </a:avLst>
           </a:prstGeom>
           <a:solidFill>
@@ -6162,7 +5722,7 @@
       </p:sp>
       <p:pic>
         <p:nvPicPr>
-          <p:cNvPr id="9" name="Image 1" descr="D:\Github\HA-Notes\LIS\skills\design-review-pptx\assets\icons\png\accent\sliders.png">    </p:cNvPr>
+          <p:cNvPr id="14" name="Image 1" descr="D:\Github\HA-Notes\LIS\skills\design-review-pptx\assets\icons\png\danger\rotate-left.png">    </p:cNvPr>
           <p:cNvPicPr>
             <a:picLocks noChangeAspect="1"/>
           </p:cNvPicPr>
@@ -6176,7 +5736,7 @@
         </p:blipFill>
         <p:spPr>
           <a:xfrm>
-            <a:off x="4617720" y="3180874"/>
+            <a:off x="6521196" y="3090101"/>
             <a:ext cx="265176" cy="265176"/>
           </a:xfrm>
           <a:prstGeom prst="rect">
@@ -6186,28 +5746,28 @@
       </p:pic>
       <p:sp>
         <p:nvSpPr>
-          <p:cNvPr id="10" name="Text 6"/>
-          <p:cNvSpPr/>
-          <p:nvPr/>
-        </p:nvSpPr>
-        <p:spPr>
-          <a:xfrm>
-            <a:off x="4617720" y="3638074"/>
-            <a:ext cx="2956560" cy="219075"/>
-          </a:xfrm>
-          <a:prstGeom prst="rect">
-            <a:avLst/>
-          </a:prstGeom>
-          <a:noFill/>
-          <a:ln/>
-        </p:spPr>
-        <p:txBody>
-          <a:bodyPr wrap="square" lIns="0" tIns="0" rIns="0" bIns="0" rtlCol="0" anchor="t"/>
-          <a:lstStyle/>
-          <a:p>
-            <a:pPr algn="l" indent="0" marL="0">
-              <a:lnSpc>
-                <a:spcPct val="110000"/>
+          <p:cNvPr id="15" name="Text 11"/>
+          <p:cNvSpPr/>
+          <p:nvPr/>
+        </p:nvSpPr>
+        <p:spPr>
+          <a:xfrm>
+            <a:off x="6886956" y="3076385"/>
+            <a:ext cx="4421124" cy="292608"/>
+          </a:xfrm>
+          <a:prstGeom prst="rect">
+            <a:avLst/>
+          </a:prstGeom>
+          <a:noFill/>
+          <a:ln/>
+        </p:spPr>
+        <p:txBody>
+          <a:bodyPr wrap="square" lIns="0" tIns="0" rIns="0" bIns="0" rtlCol="0" anchor="ctr"/>
+          <a:lstStyle/>
+          <a:p>
+            <a:pPr algn="l" indent="0" marL="0">
+              <a:lnSpc>
+                <a:spcPct val="115000"/>
               </a:lnSpc>
               <a:buNone/>
             </a:pPr>
@@ -6220,7 +5780,7 @@
                 <a:ea typeface="Segoe UI Semibold" pitchFamily="34" charset="-122"/>
                 <a:cs typeface="Segoe UI Semibold" pitchFamily="34" charset="-120"/>
               </a:rPr>
-              <a:t>No config change</a:t>
+              <a:t>Fallback</a:t>
             </a:r>
             <a:endParaRPr lang="en-US" sz="1500" dirty="0"/>
           </a:p>
@@ -6228,107 +5788,59 @@
       </p:sp>
       <p:sp>
         <p:nvSpPr>
-          <p:cNvPr id="11" name="Text 7"/>
-          <p:cNvSpPr/>
-          <p:nvPr/>
-        </p:nvSpPr>
-        <p:spPr>
-          <a:xfrm>
-            <a:off x="4617720" y="3948589"/>
-            <a:ext cx="2956560" cy="798385"/>
-          </a:xfrm>
-          <a:prstGeom prst="rect">
-            <a:avLst/>
-          </a:prstGeom>
-          <a:noFill/>
-          <a:ln/>
-        </p:spPr>
-        <p:txBody>
-          <a:bodyPr wrap="square" lIns="0" tIns="0" rIns="0" bIns="0" rtlCol="0" anchor="t"/>
-          <a:lstStyle/>
-          <a:p>
-            <a:pPr algn="l" indent="0" marL="0">
-              <a:lnSpc>
-                <a:spcPct val="120000"/>
-              </a:lnSpc>
-              <a:buNone/>
-            </a:pPr>
-            <a:r>
-              <a:rPr lang="en-US" sz="1350" dirty="0">
-                <a:solidFill>
-                  <a:srgbClr val="475569"/>
+          <p:cNvPr id="16" name="Text 12"/>
+          <p:cNvSpPr/>
+          <p:nvPr/>
+        </p:nvSpPr>
+        <p:spPr>
+          <a:xfrm>
+            <a:off x="6521196" y="3506153"/>
+            <a:ext cx="228600" cy="228600"/>
+          </a:xfrm>
+          <a:prstGeom prst="ellipse">
+            <a:avLst/>
+          </a:prstGeom>
+          <a:solidFill>
+            <a:srgbClr val="FEE2E2"/>
+          </a:solidFill>
+          <a:ln>
+            <a:solidFill>
+              <a:srgbClr val="FEE2E2"/>
+            </a:solidFill>
+          </a:ln>
+        </p:spPr>
+        <p:txBody>
+          <a:bodyPr wrap="square" lIns="0" tIns="0" rIns="0" bIns="0" rtlCol="0" anchor="ctr"/>
+          <a:lstStyle/>
+          <a:p>
+            <a:pPr algn="ctr" indent="0" marL="0">
+              <a:buNone/>
+            </a:pPr>
+            <a:r>
+              <a:rPr lang="en-US" sz="975" b="1" dirty="0">
+                <a:solidFill>
+                  <a:srgbClr val="B91C1C"/>
                 </a:solidFill>
                 <a:latin typeface="Segoe UI" pitchFamily="34" charset="0"/>
                 <a:ea typeface="Segoe UI" pitchFamily="34" charset="-122"/>
                 <a:cs typeface="Segoe UI" pitchFamily="34" charset="-120"/>
               </a:rPr>
-              <a:t>JDBC settings stay as they are in DEVQA, SIT, and PROD.</a:t>
-            </a:r>
-            <a:endParaRPr lang="en-US" sz="1350" dirty="0"/>
-          </a:p>
-        </p:txBody>
-      </p:sp>
-      <p:sp>
-        <p:nvSpPr>
-          <p:cNvPr id="12" name="Shape 8"/>
-          <p:cNvSpPr/>
-          <p:nvPr/>
-        </p:nvSpPr>
-        <p:spPr>
-          <a:xfrm>
-            <a:off x="8077200" y="2860834"/>
-            <a:ext cx="3505200" cy="2050732"/>
-          </a:xfrm>
-          <a:prstGeom prst="roundRect">
-            <a:avLst>
-              <a:gd name="adj" fmla="val 5351"/>
-            </a:avLst>
-          </a:prstGeom>
-          <a:solidFill>
-            <a:srgbClr val="FFFFFF"/>
-          </a:solidFill>
-          <a:ln w="9525">
-            <a:solidFill>
-              <a:srgbClr val="E2E8F0"/>
-            </a:solidFill>
-            <a:prstDash val="solid"/>
-          </a:ln>
-        </p:spPr>
-      </p:sp>
-      <p:pic>
-        <p:nvPicPr>
-          <p:cNvPr id="13" name="Image 2" descr="D:\Github\HA-Notes\LIS\skills\design-review-pptx\assets\icons\png\accent\box.png">    </p:cNvPr>
-          <p:cNvPicPr>
-            <a:picLocks noChangeAspect="1"/>
-          </p:cNvPicPr>
-          <p:nvPr/>
-        </p:nvPicPr>
-        <p:blipFill>
-          <a:blip r:embed="rId3"/>
-          <a:stretch>
-            <a:fillRect/>
-          </a:stretch>
-        </p:blipFill>
-        <p:spPr>
-          <a:xfrm>
-            <a:off x="8351520" y="3180874"/>
-            <a:ext cx="265176" cy="265176"/>
-          </a:xfrm>
-          <a:prstGeom prst="rect">
-            <a:avLst/>
-          </a:prstGeom>
-        </p:spPr>
-      </p:pic>
-      <p:sp>
-        <p:nvSpPr>
-          <p:cNvPr id="14" name="Text 9"/>
-          <p:cNvSpPr/>
-          <p:nvPr/>
-        </p:nvSpPr>
-        <p:spPr>
-          <a:xfrm>
-            <a:off x="8351520" y="3638074"/>
-            <a:ext cx="2956560" cy="219075"/>
+              <a:t>1</a:t>
+            </a:r>
+            <a:endParaRPr lang="en-US" sz="975" dirty="0"/>
+          </a:p>
+        </p:txBody>
+      </p:sp>
+      <p:sp>
+        <p:nvSpPr>
+          <p:cNvPr id="17" name="Text 13"/>
+          <p:cNvSpPr/>
+          <p:nvPr/>
+        </p:nvSpPr>
+        <p:spPr>
+          <a:xfrm>
+            <a:off x="6859524" y="3533585"/>
+            <a:ext cx="4448556" cy="196882"/>
           </a:xfrm>
           <a:prstGeom prst="rect">
             <a:avLst/>
@@ -6342,64 +5854,196 @@
           <a:p>
             <a:pPr algn="l" indent="0" marL="0">
               <a:lnSpc>
-                <a:spcPct val="110000"/>
-              </a:lnSpc>
-              <a:buNone/>
-            </a:pPr>
-            <a:r>
-              <a:rPr lang="en-US" sz="1500" dirty="0">
-                <a:solidFill>
-                  <a:srgbClr val="0F172A"/>
-                </a:solidFill>
-                <a:latin typeface="Segoe UI Semibold" pitchFamily="34" charset="0"/>
-                <a:ea typeface="Segoe UI Semibold" pitchFamily="34" charset="-122"/>
-                <a:cs typeface="Segoe UI Semibold" pitchFamily="34" charset="-120"/>
-              </a:rPr>
-              <a:t>Patient sync only rebuilds</a:t>
-            </a:r>
-            <a:endParaRPr lang="en-US" sz="1500" dirty="0"/>
-          </a:p>
-        </p:txBody>
-      </p:sp>
-      <p:sp>
-        <p:nvSpPr>
-          <p:cNvPr id="15" name="Text 10"/>
-          <p:cNvSpPr/>
-          <p:nvPr/>
-        </p:nvSpPr>
-        <p:spPr>
-          <a:xfrm>
-            <a:off x="8351520" y="3948589"/>
-            <a:ext cx="2956560" cy="798385"/>
-          </a:xfrm>
-          <a:prstGeom prst="rect">
-            <a:avLst/>
-          </a:prstGeom>
-          <a:noFill/>
-          <a:ln/>
-        </p:spPr>
-        <p:txBody>
-          <a:bodyPr wrap="square" lIns="0" tIns="0" rIns="0" bIns="0" rtlCol="0" anchor="t"/>
-          <a:lstStyle/>
-          <a:p>
-            <a:pPr algn="l" indent="0" marL="0">
-              <a:lnSpc>
-                <a:spcPct val="120000"/>
-              </a:lnSpc>
-              <a:buNone/>
-            </a:pPr>
-            <a:r>
-              <a:rPr lang="en-US" sz="1350" dirty="0">
-                <a:solidFill>
-                  <a:srgbClr val="475569"/>
+                <a:spcPct val="115000"/>
+              </a:lnSpc>
+              <a:buNone/>
+            </a:pPr>
+            <a:r>
+              <a:rPr lang="en-US" sz="1125" dirty="0">
+                <a:solidFill>
+                  <a:srgbClr val="334155"/>
                 </a:solidFill>
                 <a:latin typeface="Segoe UI" pitchFamily="34" charset="0"/>
                 <a:ea typeface="Segoe UI" pitchFamily="34" charset="-122"/>
                 <a:cs typeface="Segoe UI" pitchFamily="34" charset="-120"/>
               </a:rPr>
-              <a:t>lis-patient-pmi-sync-svc rebuilds to take the library. Its own source stays the same.</a:t>
-            </a:r>
-            <a:endParaRPr lang="en-US" sz="1350" dirty="0"/>
+              <a:t>Redeploy the previous data-source build and restart</a:t>
+            </a:r>
+            <a:endParaRPr lang="en-US" sz="1125" dirty="0"/>
+          </a:p>
+        </p:txBody>
+      </p:sp>
+      <p:sp>
+        <p:nvSpPr>
+          <p:cNvPr id="18" name="Text 14"/>
+          <p:cNvSpPr/>
+          <p:nvPr/>
+        </p:nvSpPr>
+        <p:spPr>
+          <a:xfrm>
+            <a:off x="6521196" y="3840194"/>
+            <a:ext cx="228600" cy="228600"/>
+          </a:xfrm>
+          <a:prstGeom prst="ellipse">
+            <a:avLst/>
+          </a:prstGeom>
+          <a:solidFill>
+            <a:srgbClr val="FEE2E2"/>
+          </a:solidFill>
+          <a:ln>
+            <a:solidFill>
+              <a:srgbClr val="FEE2E2"/>
+            </a:solidFill>
+          </a:ln>
+        </p:spPr>
+        <p:txBody>
+          <a:bodyPr wrap="square" lIns="0" tIns="0" rIns="0" bIns="0" rtlCol="0" anchor="ctr"/>
+          <a:lstStyle/>
+          <a:p>
+            <a:pPr algn="ctr" indent="0" marL="0">
+              <a:buNone/>
+            </a:pPr>
+            <a:r>
+              <a:rPr lang="en-US" sz="975" b="1" dirty="0">
+                <a:solidFill>
+                  <a:srgbClr val="B91C1C"/>
+                </a:solidFill>
+                <a:latin typeface="Segoe UI" pitchFamily="34" charset="0"/>
+                <a:ea typeface="Segoe UI" pitchFamily="34" charset="-122"/>
+                <a:cs typeface="Segoe UI" pitchFamily="34" charset="-120"/>
+              </a:rPr>
+              <a:t>2</a:t>
+            </a:r>
+            <a:endParaRPr lang="en-US" sz="975" dirty="0"/>
+          </a:p>
+        </p:txBody>
+      </p:sp>
+      <p:sp>
+        <p:nvSpPr>
+          <p:cNvPr id="19" name="Text 15"/>
+          <p:cNvSpPr/>
+          <p:nvPr/>
+        </p:nvSpPr>
+        <p:spPr>
+          <a:xfrm>
+            <a:off x="6859524" y="3867626"/>
+            <a:ext cx="4448556" cy="375476"/>
+          </a:xfrm>
+          <a:prstGeom prst="rect">
+            <a:avLst/>
+          </a:prstGeom>
+          <a:noFill/>
+          <a:ln/>
+        </p:spPr>
+        <p:txBody>
+          <a:bodyPr wrap="square" lIns="0" tIns="0" rIns="0" bIns="0" rtlCol="0" anchor="t"/>
+          <a:lstStyle/>
+          <a:p>
+            <a:pPr algn="l" indent="0" marL="0">
+              <a:lnSpc>
+                <a:spcPct val="115000"/>
+              </a:lnSpc>
+              <a:buNone/>
+            </a:pPr>
+            <a:r>
+              <a:rPr lang="en-US" sz="1125" dirty="0">
+                <a:solidFill>
+                  <a:srgbClr val="334155"/>
+                </a:solidFill>
+                <a:latin typeface="Segoe UI" pitchFamily="34" charset="0"/>
+                <a:ea typeface="Segoe UI" pitchFamily="34" charset="-122"/>
+                <a:cs typeface="Segoe UI" pitchFamily="34" charset="-120"/>
+              </a:rPr>
+              <a:t>On a Sybase hospital, the log again says defaulting to PostgreSQL</a:t>
+            </a:r>
+            <a:endParaRPr lang="en-US" sz="1125" dirty="0"/>
+          </a:p>
+        </p:txBody>
+      </p:sp>
+      <p:sp>
+        <p:nvSpPr>
+          <p:cNvPr id="20" name="Text 16"/>
+          <p:cNvSpPr/>
+          <p:nvPr/>
+        </p:nvSpPr>
+        <p:spPr>
+          <a:xfrm>
+            <a:off x="6521196" y="4352830"/>
+            <a:ext cx="228600" cy="228600"/>
+          </a:xfrm>
+          <a:prstGeom prst="ellipse">
+            <a:avLst/>
+          </a:prstGeom>
+          <a:solidFill>
+            <a:srgbClr val="FEE2E2"/>
+          </a:solidFill>
+          <a:ln>
+            <a:solidFill>
+              <a:srgbClr val="FEE2E2"/>
+            </a:solidFill>
+          </a:ln>
+        </p:spPr>
+        <p:txBody>
+          <a:bodyPr wrap="square" lIns="0" tIns="0" rIns="0" bIns="0" rtlCol="0" anchor="ctr"/>
+          <a:lstStyle/>
+          <a:p>
+            <a:pPr algn="ctr" indent="0" marL="0">
+              <a:buNone/>
+            </a:pPr>
+            <a:r>
+              <a:rPr lang="en-US" sz="975" b="1" dirty="0">
+                <a:solidFill>
+                  <a:srgbClr val="B91C1C"/>
+                </a:solidFill>
+                <a:latin typeface="Segoe UI" pitchFamily="34" charset="0"/>
+                <a:ea typeface="Segoe UI" pitchFamily="34" charset="-122"/>
+                <a:cs typeface="Segoe UI" pitchFamily="34" charset="-120"/>
+              </a:rPr>
+              <a:t>3</a:t>
+            </a:r>
+            <a:endParaRPr lang="en-US" sz="975" dirty="0"/>
+          </a:p>
+        </p:txBody>
+      </p:sp>
+      <p:sp>
+        <p:nvSpPr>
+          <p:cNvPr id="21" name="Text 17"/>
+          <p:cNvSpPr/>
+          <p:nvPr/>
+        </p:nvSpPr>
+        <p:spPr>
+          <a:xfrm>
+            <a:off x="6859524" y="4380262"/>
+            <a:ext cx="4448556" cy="196882"/>
+          </a:xfrm>
+          <a:prstGeom prst="rect">
+            <a:avLst/>
+          </a:prstGeom>
+          <a:noFill/>
+          <a:ln/>
+        </p:spPr>
+        <p:txBody>
+          <a:bodyPr wrap="square" lIns="0" tIns="0" rIns="0" bIns="0" rtlCol="0" anchor="t"/>
+          <a:lstStyle/>
+          <a:p>
+            <a:pPr algn="l" indent="0" marL="0">
+              <a:lnSpc>
+                <a:spcPct val="115000"/>
+              </a:lnSpc>
+              <a:buNone/>
+            </a:pPr>
+            <a:r>
+              <a:rPr lang="en-US" sz="1125" dirty="0">
+                <a:solidFill>
+                  <a:srgbClr val="334155"/>
+                </a:solidFill>
+                <a:latin typeface="Segoe UI" pitchFamily="34" charset="0"/>
+                <a:ea typeface="Segoe UI" pitchFamily="34" charset="-122"/>
+                <a:cs typeface="Segoe UI" pitchFamily="34" charset="-120"/>
+              </a:rPr>
+              <a:t>Drop one cached type check for that hospital and lab</a:t>
+            </a:r>
+            <a:endParaRPr lang="en-US" sz="1125" dirty="0"/>
           </a:p>
         </p:txBody>
       </p:sp>
@@ -6468,7 +6112,7 @@
                 <a:ea typeface="Segoe UI Semibold" pitchFamily="34" charset="-122"/>
                 <a:cs typeface="Segoe UI Semibold" pitchFamily="34" charset="-120"/>
               </a:rPr>
-              <a:t>FALLBACK</a:t>
+              <a:t>OPEN QUESTIONS</a:t>
             </a:r>
             <a:endParaRPr lang="en-US" sz="1050" dirty="0"/>
           </a:p>
@@ -6507,7 +6151,7 @@
                 <a:ea typeface="Segoe UI Semibold" pitchFamily="34" charset="-122"/>
                 <a:cs typeface="Segoe UI Semibold" pitchFamily="34" charset="-120"/>
               </a:rPr>
-              <a:t>Put the previous library back</a:t>
+              <a:t>Two questions before we build</a:t>
             </a:r>
             <a:endParaRPr lang="en-US" sz="2400" dirty="0"/>
           </a:p>
@@ -6521,12 +6165,12 @@
         </p:nvSpPr>
         <p:spPr>
           <a:xfrm>
-            <a:off x="609600" y="2869978"/>
-            <a:ext cx="3505200" cy="2032444"/>
+            <a:off x="609600" y="3024378"/>
+            <a:ext cx="10972800" cy="797814"/>
           </a:xfrm>
           <a:prstGeom prst="roundRect">
             <a:avLst>
-              <a:gd name="adj" fmla="val 5399"/>
+              <a:gd name="adj" fmla="val 13754"/>
             </a:avLst>
           </a:prstGeom>
           <a:solidFill>
@@ -6548,53 +6192,92 @@
         </p:nvSpPr>
         <p:spPr>
           <a:xfrm>
-            <a:off x="883920" y="3190018"/>
-            <a:ext cx="310896" cy="310896"/>
-          </a:xfrm>
-          <a:prstGeom prst="ellipse">
-            <a:avLst/>
-          </a:prstGeom>
-          <a:solidFill>
-            <a:srgbClr val="E0F2FE"/>
-          </a:solidFill>
-          <a:ln>
-            <a:solidFill>
-              <a:srgbClr val="E0F2FE"/>
-            </a:solidFill>
-          </a:ln>
+            <a:off x="847344" y="3024378"/>
+            <a:ext cx="502920" cy="797814"/>
+          </a:xfrm>
+          <a:prstGeom prst="rect">
+            <a:avLst/>
+          </a:prstGeom>
+          <a:noFill/>
+          <a:ln/>
         </p:spPr>
         <p:txBody>
           <a:bodyPr wrap="square" lIns="0" tIns="0" rIns="0" bIns="0" rtlCol="0" anchor="ctr"/>
           <a:lstStyle/>
           <a:p>
-            <a:pPr algn="ctr" indent="0" marL="0">
-              <a:buNone/>
-            </a:pPr>
-            <a:r>
-              <a:rPr lang="en-US" sz="1125" b="1" dirty="0">
-                <a:solidFill>
-                  <a:srgbClr val="0369A1"/>
+            <a:pPr algn="l" indent="0" marL="0">
+              <a:lnSpc>
+                <a:spcPct val="115000"/>
+              </a:lnSpc>
+              <a:buNone/>
+            </a:pPr>
+            <a:r>
+              <a:rPr lang="en-US" sz="1500" dirty="0">
+                <a:solidFill>
+                  <a:srgbClr val="0284C7"/>
+                </a:solidFill>
+                <a:latin typeface="Segoe UI Semibold" pitchFamily="34" charset="0"/>
+                <a:ea typeface="Segoe UI Semibold" pitchFamily="34" charset="-122"/>
+                <a:cs typeface="Segoe UI Semibold" pitchFamily="34" charset="-120"/>
+              </a:rPr>
+              <a:t>01</a:t>
+            </a:r>
+            <a:endParaRPr lang="en-US" sz="1500" dirty="0"/>
+          </a:p>
+        </p:txBody>
+      </p:sp>
+      <p:sp>
+        <p:nvSpPr>
+          <p:cNvPr id="6" name="Text 4"/>
+          <p:cNvSpPr/>
+          <p:nvPr/>
+        </p:nvSpPr>
+        <p:spPr>
+          <a:xfrm>
+            <a:off x="1341120" y="3207258"/>
+            <a:ext cx="10003536" cy="205740"/>
+          </a:xfrm>
+          <a:prstGeom prst="rect">
+            <a:avLst/>
+          </a:prstGeom>
+          <a:noFill/>
+          <a:ln/>
+        </p:spPr>
+        <p:txBody>
+          <a:bodyPr wrap="square" lIns="0" tIns="0" rIns="0" bIns="0" rtlCol="0" anchor="t"/>
+          <a:lstStyle/>
+          <a:p>
+            <a:pPr algn="l" indent="0" marL="0">
+              <a:lnSpc>
+                <a:spcPct val="110000"/>
+              </a:lnSpc>
+              <a:buNone/>
+            </a:pPr>
+            <a:r>
+              <a:rPr lang="en-US" sz="1350" b="1" dirty="0">
+                <a:solidFill>
+                  <a:srgbClr val="0F172A"/>
                 </a:solidFill>
                 <a:latin typeface="Segoe UI" pitchFamily="34" charset="0"/>
                 <a:ea typeface="Segoe UI" pitchFamily="34" charset="-122"/>
                 <a:cs typeface="Segoe UI" pitchFamily="34" charset="-120"/>
               </a:rPr>
-              <a:t>1</a:t>
-            </a:r>
-            <a:endParaRPr lang="en-US" sz="1125" dirty="0"/>
-          </a:p>
-        </p:txBody>
-      </p:sp>
-      <p:sp>
-        <p:nvSpPr>
-          <p:cNvPr id="6" name="Text 4"/>
-          <p:cNvSpPr/>
-          <p:nvPr/>
-        </p:nvSpPr>
-        <p:spPr>
-          <a:xfrm>
-            <a:off x="883920" y="3628930"/>
-            <a:ext cx="2956560" cy="219075"/>
+              <a:t>Is LOE / lab 1 / LOE_DB the only Oracle database?</a:t>
+            </a:r>
+            <a:endParaRPr lang="en-US" sz="1350" dirty="0"/>
+          </a:p>
+        </p:txBody>
+      </p:sp>
+      <p:sp>
+        <p:nvSpPr>
+          <p:cNvPr id="7" name="Text 5"/>
+          <p:cNvSpPr/>
+          <p:nvPr/>
+        </p:nvSpPr>
+        <p:spPr>
+          <a:xfrm>
+            <a:off x="1341120" y="3467862"/>
+            <a:ext cx="10003536" cy="171450"/>
           </a:xfrm>
           <a:prstGeom prst="rect">
             <a:avLst/>
@@ -6613,59 +6296,17 @@
               <a:buNone/>
             </a:pPr>
             <a:r>
-              <a:rPr lang="en-US" sz="1500" dirty="0">
-                <a:solidFill>
-                  <a:srgbClr val="0F172A"/>
-                </a:solidFill>
-                <a:latin typeface="Segoe UI Semibold" pitchFamily="34" charset="0"/>
-                <a:ea typeface="Segoe UI Semibold" pitchFamily="34" charset="-122"/>
-                <a:cs typeface="Segoe UI Semibold" pitchFamily="34" charset="-120"/>
-              </a:rPr>
-              <a:t>Redeploy and restart</a:t>
-            </a:r>
-            <a:endParaRPr lang="en-US" sz="1500" dirty="0"/>
-          </a:p>
-        </p:txBody>
-      </p:sp>
-      <p:sp>
-        <p:nvSpPr>
-          <p:cNvPr id="7" name="Text 5"/>
-          <p:cNvSpPr/>
-          <p:nvPr/>
-        </p:nvSpPr>
-        <p:spPr>
-          <a:xfrm>
-            <a:off x="883920" y="3939445"/>
-            <a:ext cx="2956560" cy="798385"/>
-          </a:xfrm>
-          <a:prstGeom prst="rect">
-            <a:avLst/>
-          </a:prstGeom>
-          <a:noFill/>
-          <a:ln/>
-        </p:spPr>
-        <p:txBody>
-          <a:bodyPr wrap="square" lIns="0" tIns="0" rIns="0" bIns="0" rtlCol="0" anchor="t"/>
-          <a:lstStyle/>
-          <a:p>
-            <a:pPr algn="l" indent="0" marL="0">
-              <a:lnSpc>
-                <a:spcPct val="120000"/>
-              </a:lnSpc>
-              <a:buNone/>
-            </a:pPr>
-            <a:r>
-              <a:rPr lang="en-US" sz="1350" dirty="0">
-                <a:solidFill>
-                  <a:srgbClr val="475569"/>
+              <a:rPr lang="en-US" sz="1125" dirty="0">
+                <a:solidFill>
+                  <a:srgbClr val="64748B"/>
                 </a:solidFill>
                 <a:latin typeface="Segoe UI" pitchFamily="34" charset="0"/>
                 <a:ea typeface="Segoe UI" pitchFamily="34" charset="-122"/>
                 <a:cs typeface="Segoe UI" pitchFamily="34" charset="-120"/>
               </a:rPr>
-              <a:t>Put the previous data-source build back on the affected service and restart it.</a:t>
-            </a:r>
-            <a:endParaRPr lang="en-US" sz="1350" dirty="0"/>
+              <a:t>The flag read will use that connection unless the thread is already on Oracle.</a:t>
+            </a:r>
+            <a:endParaRPr lang="en-US" sz="1125" dirty="0"/>
           </a:p>
         </p:txBody>
       </p:sp>
@@ -6677,12 +6318,12 @@
         </p:nvSpPr>
         <p:spPr>
           <a:xfrm>
-            <a:off x="4343400" y="2869978"/>
-            <a:ext cx="3505200" cy="2032444"/>
+            <a:off x="609600" y="3950208"/>
+            <a:ext cx="10972800" cy="797814"/>
           </a:xfrm>
           <a:prstGeom prst="roundRect">
             <a:avLst>
-              <a:gd name="adj" fmla="val 5399"/>
+              <a:gd name="adj" fmla="val 13754"/>
             </a:avLst>
           </a:prstGeom>
           <a:solidFill>
@@ -6704,53 +6345,92 @@
         </p:nvSpPr>
         <p:spPr>
           <a:xfrm>
-            <a:off x="4617720" y="3190018"/>
-            <a:ext cx="310896" cy="310896"/>
-          </a:xfrm>
-          <a:prstGeom prst="ellipse">
-            <a:avLst/>
-          </a:prstGeom>
-          <a:solidFill>
-            <a:srgbClr val="E0F2FE"/>
-          </a:solidFill>
-          <a:ln>
-            <a:solidFill>
-              <a:srgbClr val="E0F2FE"/>
-            </a:solidFill>
-          </a:ln>
+            <a:off x="847344" y="3950208"/>
+            <a:ext cx="502920" cy="797814"/>
+          </a:xfrm>
+          <a:prstGeom prst="rect">
+            <a:avLst/>
+          </a:prstGeom>
+          <a:noFill/>
+          <a:ln/>
         </p:spPr>
         <p:txBody>
           <a:bodyPr wrap="square" lIns="0" tIns="0" rIns="0" bIns="0" rtlCol="0" anchor="ctr"/>
           <a:lstStyle/>
           <a:p>
-            <a:pPr algn="ctr" indent="0" marL="0">
-              <a:buNone/>
-            </a:pPr>
-            <a:r>
-              <a:rPr lang="en-US" sz="1125" b="1" dirty="0">
-                <a:solidFill>
-                  <a:srgbClr val="0369A1"/>
+            <a:pPr algn="l" indent="0" marL="0">
+              <a:lnSpc>
+                <a:spcPct val="115000"/>
+              </a:lnSpc>
+              <a:buNone/>
+            </a:pPr>
+            <a:r>
+              <a:rPr lang="en-US" sz="1500" dirty="0">
+                <a:solidFill>
+                  <a:srgbClr val="0284C7"/>
+                </a:solidFill>
+                <a:latin typeface="Segoe UI Semibold" pitchFamily="34" charset="0"/>
+                <a:ea typeface="Segoe UI Semibold" pitchFamily="34" charset="-122"/>
+                <a:cs typeface="Segoe UI Semibold" pitchFamily="34" charset="-120"/>
+              </a:rPr>
+              <a:t>02</a:t>
+            </a:r>
+            <a:endParaRPr lang="en-US" sz="1500" dirty="0"/>
+          </a:p>
+        </p:txBody>
+      </p:sp>
+      <p:sp>
+        <p:nvSpPr>
+          <p:cNvPr id="10" name="Text 8"/>
+          <p:cNvSpPr/>
+          <p:nvPr/>
+        </p:nvSpPr>
+        <p:spPr>
+          <a:xfrm>
+            <a:off x="1341120" y="4133088"/>
+            <a:ext cx="10003536" cy="205740"/>
+          </a:xfrm>
+          <a:prstGeom prst="rect">
+            <a:avLst/>
+          </a:prstGeom>
+          <a:noFill/>
+          <a:ln/>
+        </p:spPr>
+        <p:txBody>
+          <a:bodyPr wrap="square" lIns="0" tIns="0" rIns="0" bIns="0" rtlCol="0" anchor="t"/>
+          <a:lstStyle/>
+          <a:p>
+            <a:pPr algn="l" indent="0" marL="0">
+              <a:lnSpc>
+                <a:spcPct val="110000"/>
+              </a:lnSpc>
+              <a:buNone/>
+            </a:pPr>
+            <a:r>
+              <a:rPr lang="en-US" sz="1350" b="1" dirty="0">
+                <a:solidFill>
+                  <a:srgbClr val="0F172A"/>
                 </a:solidFill>
                 <a:latin typeface="Segoe UI" pitchFamily="34" charset="0"/>
                 <a:ea typeface="Segoe UI" pitchFamily="34" charset="-122"/>
                 <a:cs typeface="Segoe UI" pitchFamily="34" charset="-120"/>
               </a:rPr>
-              <a:t>2</a:t>
-            </a:r>
-            <a:endParaRPr lang="en-US" sz="1125" dirty="0"/>
-          </a:p>
-        </p:txBody>
-      </p:sp>
-      <p:sp>
-        <p:nvSpPr>
-          <p:cNvPr id="10" name="Text 8"/>
-          <p:cNvSpPr/>
-          <p:nvPr/>
-        </p:nvSpPr>
-        <p:spPr>
-          <a:xfrm>
-            <a:off x="4617720" y="3628930"/>
-            <a:ext cx="2956560" cy="219075"/>
+              <a:t>If a distributed transaction is already open, may this Oracle read join it?</a:t>
+            </a:r>
+            <a:endParaRPr lang="en-US" sz="1350" dirty="0"/>
+          </a:p>
+        </p:txBody>
+      </p:sp>
+      <p:sp>
+        <p:nvSpPr>
+          <p:cNvPr id="11" name="Text 9"/>
+          <p:cNvSpPr/>
+          <p:nvPr/>
+        </p:nvSpPr>
+        <p:spPr>
+          <a:xfrm>
+            <a:off x="1341120" y="4393692"/>
+            <a:ext cx="10003536" cy="171450"/>
           </a:xfrm>
           <a:prstGeom prst="rect">
             <a:avLst/>
@@ -6769,215 +6449,17 @@
               <a:buNone/>
             </a:pPr>
             <a:r>
-              <a:rPr lang="en-US" sz="1500" dirty="0">
-                <a:solidFill>
-                  <a:srgbClr val="0F172A"/>
-                </a:solidFill>
-                <a:latin typeface="Segoe UI Semibold" pitchFamily="34" charset="0"/>
-                <a:ea typeface="Segoe UI Semibold" pitchFamily="34" charset="-122"/>
-                <a:cs typeface="Segoe UI Semibold" pitchFamily="34" charset="-120"/>
-              </a:rPr>
-              <a:t>Watch for the old warning</a:t>
-            </a:r>
-            <a:endParaRPr lang="en-US" sz="1500" dirty="0"/>
-          </a:p>
-        </p:txBody>
-      </p:sp>
-      <p:sp>
-        <p:nvSpPr>
-          <p:cNvPr id="11" name="Text 9"/>
-          <p:cNvSpPr/>
-          <p:nvPr/>
-        </p:nvSpPr>
-        <p:spPr>
-          <a:xfrm>
-            <a:off x="4617720" y="3939445"/>
-            <a:ext cx="2956560" cy="798385"/>
-          </a:xfrm>
-          <a:prstGeom prst="rect">
-            <a:avLst/>
-          </a:prstGeom>
-          <a:noFill/>
-          <a:ln/>
-        </p:spPr>
-        <p:txBody>
-          <a:bodyPr wrap="square" lIns="0" tIns="0" rIns="0" bIns="0" rtlCol="0" anchor="t"/>
-          <a:lstStyle/>
-          <a:p>
-            <a:pPr algn="l" indent="0" marL="0">
-              <a:lnSpc>
-                <a:spcPct val="120000"/>
-              </a:lnSpc>
-              <a:buNone/>
-            </a:pPr>
-            <a:r>
-              <a:rPr lang="en-US" sz="1350" dirty="0">
-                <a:solidFill>
-                  <a:srgbClr val="475569"/>
+              <a:rPr lang="en-US" sz="1125" dirty="0">
+                <a:solidFill>
+                  <a:srgbClr val="64748B"/>
                 </a:solidFill>
                 <a:latin typeface="Segoe UI" pitchFamily="34" charset="0"/>
                 <a:ea typeface="Segoe UI" pitchFamily="34" charset="-122"/>
                 <a:cs typeface="Segoe UI" pitchFamily="34" charset="-120"/>
               </a:rPr>
-              <a:t>On a Sybase hospital, the log should again say defaulting to PostgreSQL.</a:t>
-            </a:r>
-            <a:endParaRPr lang="en-US" sz="1350" dirty="0"/>
-          </a:p>
-        </p:txBody>
-      </p:sp>
-      <p:sp>
-        <p:nvSpPr>
-          <p:cNvPr id="12" name="Shape 10"/>
-          <p:cNvSpPr/>
-          <p:nvPr/>
-        </p:nvSpPr>
-        <p:spPr>
-          <a:xfrm>
-            <a:off x="8077200" y="2869978"/>
-            <a:ext cx="3505200" cy="2032444"/>
-          </a:xfrm>
-          <a:prstGeom prst="roundRect">
-            <a:avLst>
-              <a:gd name="adj" fmla="val 5399"/>
-            </a:avLst>
-          </a:prstGeom>
-          <a:solidFill>
-            <a:srgbClr val="FFFFFF"/>
-          </a:solidFill>
-          <a:ln w="9525">
-            <a:solidFill>
-              <a:srgbClr val="E2E8F0"/>
-            </a:solidFill>
-            <a:prstDash val="solid"/>
-          </a:ln>
-        </p:spPr>
-      </p:sp>
-      <p:sp>
-        <p:nvSpPr>
-          <p:cNvPr id="13" name="Text 11"/>
-          <p:cNvSpPr/>
-          <p:nvPr/>
-        </p:nvSpPr>
-        <p:spPr>
-          <a:xfrm>
-            <a:off x="8351520" y="3190018"/>
-            <a:ext cx="310896" cy="310896"/>
-          </a:xfrm>
-          <a:prstGeom prst="ellipse">
-            <a:avLst/>
-          </a:prstGeom>
-          <a:solidFill>
-            <a:srgbClr val="E0F2FE"/>
-          </a:solidFill>
-          <a:ln>
-            <a:solidFill>
-              <a:srgbClr val="E0F2FE"/>
-            </a:solidFill>
-          </a:ln>
-        </p:spPr>
-        <p:txBody>
-          <a:bodyPr wrap="square" lIns="0" tIns="0" rIns="0" bIns="0" rtlCol="0" anchor="ctr"/>
-          <a:lstStyle/>
-          <a:p>
-            <a:pPr algn="ctr" indent="0" marL="0">
-              <a:buNone/>
-            </a:pPr>
-            <a:r>
-              <a:rPr lang="en-US" sz="1125" b="1" dirty="0">
-                <a:solidFill>
-                  <a:srgbClr val="0369A1"/>
-                </a:solidFill>
-                <a:latin typeface="Segoe UI" pitchFamily="34" charset="0"/>
-                <a:ea typeface="Segoe UI" pitchFamily="34" charset="-122"/>
-                <a:cs typeface="Segoe UI" pitchFamily="34" charset="-120"/>
-              </a:rPr>
-              <a:t>3</a:t>
+              <a:t>Hospital work will not be committed early. Transaction locking otherwise stays as LIS-10723 left it.</a:t>
             </a:r>
             <a:endParaRPr lang="en-US" sz="1125" dirty="0"/>
-          </a:p>
-        </p:txBody>
-      </p:sp>
-      <p:sp>
-        <p:nvSpPr>
-          <p:cNvPr id="14" name="Text 12"/>
-          <p:cNvSpPr/>
-          <p:nvPr/>
-        </p:nvSpPr>
-        <p:spPr>
-          <a:xfrm>
-            <a:off x="8351520" y="3628930"/>
-            <a:ext cx="2956560" cy="219075"/>
-          </a:xfrm>
-          <a:prstGeom prst="rect">
-            <a:avLst/>
-          </a:prstGeom>
-          <a:noFill/>
-          <a:ln/>
-        </p:spPr>
-        <p:txBody>
-          <a:bodyPr wrap="square" lIns="0" tIns="0" rIns="0" bIns="0" rtlCol="0" anchor="t"/>
-          <a:lstStyle/>
-          <a:p>
-            <a:pPr algn="l" indent="0" marL="0">
-              <a:lnSpc>
-                <a:spcPct val="110000"/>
-              </a:lnSpc>
-              <a:buNone/>
-            </a:pPr>
-            <a:r>
-              <a:rPr lang="en-US" sz="1500" dirty="0">
-                <a:solidFill>
-                  <a:srgbClr val="0F172A"/>
-                </a:solidFill>
-                <a:latin typeface="Segoe UI Semibold" pitchFamily="34" charset="0"/>
-                <a:ea typeface="Segoe UI Semibold" pitchFamily="34" charset="-122"/>
-                <a:cs typeface="Segoe UI Semibold" pitchFamily="34" charset="-120"/>
-              </a:rPr>
-              <a:t>Clear a wrong saved answer</a:t>
-            </a:r>
-            <a:endParaRPr lang="en-US" sz="1500" dirty="0"/>
-          </a:p>
-        </p:txBody>
-      </p:sp>
-      <p:sp>
-        <p:nvSpPr>
-          <p:cNvPr id="15" name="Text 13"/>
-          <p:cNvSpPr/>
-          <p:nvPr/>
-        </p:nvSpPr>
-        <p:spPr>
-          <a:xfrm>
-            <a:off x="8351520" y="3939445"/>
-            <a:ext cx="2956560" cy="798385"/>
-          </a:xfrm>
-          <a:prstGeom prst="rect">
-            <a:avLst/>
-          </a:prstGeom>
-          <a:noFill/>
-          <a:ln/>
-        </p:spPr>
-        <p:txBody>
-          <a:bodyPr wrap="square" lIns="0" tIns="0" rIns="0" bIns="0" rtlCol="0" anchor="t"/>
-          <a:lstStyle/>
-          <a:p>
-            <a:pPr algn="l" indent="0" marL="0">
-              <a:lnSpc>
-                <a:spcPct val="120000"/>
-              </a:lnSpc>
-              <a:buNone/>
-            </a:pPr>
-            <a:r>
-              <a:rPr lang="en-US" sz="1350" dirty="0">
-                <a:solidFill>
-                  <a:srgbClr val="475569"/>
-                </a:solidFill>
-                <a:latin typeface="Segoe UI" pitchFamily="34" charset="0"/>
-                <a:ea typeface="Segoe UI" pitchFamily="34" charset="-122"/>
-                <a:cs typeface="Segoe UI" pitchFamily="34" charset="-120"/>
-              </a:rPr>
-              <a:t>Drop one cached type check for that hospital and lab.</a:t>
-            </a:r>
-            <a:endParaRPr lang="en-US" sz="1350" dirty="0"/>
           </a:p>
         </p:txBody>
       </p:sp>
@@ -6995,7 +6477,7 @@
     <p:bg>
       <p:bgPr>
         <a:solidFill>
-          <a:srgbClr val="F8FAFC"/>
+          <a:srgbClr val="090D16"/>
         </a:solidFill>
       </p:bgPr>
     </p:bg>
@@ -7021,32 +6503,35 @@
         </p:nvSpPr>
         <p:spPr>
           <a:xfrm>
-            <a:off x="609600" y="457200"/>
-            <a:ext cx="10972800" cy="228600"/>
-          </a:xfrm>
-          <a:prstGeom prst="rect">
-            <a:avLst/>
-          </a:prstGeom>
-          <a:noFill/>
-          <a:ln/>
-        </p:spPr>
-        <p:txBody>
-          <a:bodyPr wrap="square" lIns="0" tIns="0" rIns="0" bIns="0" rtlCol="0" anchor="ctr"/>
-          <a:lstStyle/>
-          <a:p>
-            <a:pPr indent="0" marL="0">
+            <a:off x="758952" y="2722245"/>
+            <a:ext cx="9601200" cy="219456"/>
+          </a:xfrm>
+          <a:prstGeom prst="rect">
+            <a:avLst/>
+          </a:prstGeom>
+          <a:noFill/>
+          <a:ln/>
+        </p:spPr>
+        <p:txBody>
+          <a:bodyPr wrap="square" lIns="0" tIns="0" rIns="0" bIns="0" rtlCol="0" anchor="t"/>
+          <a:lstStyle/>
+          <a:p>
+            <a:pPr algn="l" indent="0" marL="0">
+              <a:lnSpc>
+                <a:spcPct val="115000"/>
+              </a:lnSpc>
               <a:buNone/>
             </a:pPr>
             <a:r>
               <a:rPr lang="en-US" sz="1050" spc="150" kern="0" dirty="0">
                 <a:solidFill>
-                  <a:srgbClr val="0284C7"/>
+                  <a:srgbClr val="38BDF8"/>
                 </a:solidFill>
                 <a:latin typeface="Segoe UI Semibold" pitchFamily="34" charset="0"/>
                 <a:ea typeface="Segoe UI Semibold" pitchFamily="34" charset="-122"/>
                 <a:cs typeface="Segoe UI Semibold" pitchFamily="34" charset="-120"/>
               </a:rPr>
-              <a:t>OPEN QUESTIONS</a:t>
+              <a:t>DISCUSSION</a:t>
             </a:r>
             <a:endParaRPr lang="en-US" sz="1050" dirty="0"/>
           </a:p>
@@ -7060,116 +6545,50 @@
         </p:nvSpPr>
         <p:spPr>
           <a:xfrm>
-            <a:off x="609600" y="722376"/>
-            <a:ext cx="10972800" cy="457200"/>
-          </a:xfrm>
-          <a:prstGeom prst="rect">
-            <a:avLst/>
-          </a:prstGeom>
-          <a:noFill/>
-          <a:ln/>
-        </p:spPr>
-        <p:txBody>
-          <a:bodyPr wrap="square" lIns="0" tIns="0" rIns="0" bIns="0" rtlCol="0" anchor="ctr"/>
-          <a:lstStyle/>
-          <a:p>
-            <a:pPr indent="0" marL="0">
-              <a:buNone/>
-            </a:pPr>
-            <a:r>
-              <a:rPr lang="en-US" sz="2400" dirty="0">
-                <a:solidFill>
-                  <a:srgbClr val="0F172A"/>
+            <a:off x="758952" y="3069717"/>
+            <a:ext cx="9601200" cy="481965"/>
+          </a:xfrm>
+          <a:prstGeom prst="rect">
+            <a:avLst/>
+          </a:prstGeom>
+          <a:noFill/>
+          <a:ln/>
+        </p:spPr>
+        <p:txBody>
+          <a:bodyPr wrap="square" lIns="0" tIns="0" rIns="0" bIns="0" rtlCol="0" anchor="t"/>
+          <a:lstStyle/>
+          <a:p>
+            <a:pPr algn="l" indent="0" marL="0">
+              <a:lnSpc>
+                <a:spcPct val="105000"/>
+              </a:lnSpc>
+              <a:buNone/>
+            </a:pPr>
+            <a:r>
+              <a:rPr lang="en-US" sz="3300" dirty="0">
+                <a:solidFill>
+                  <a:srgbClr val="FFFFFF"/>
                 </a:solidFill>
                 <a:latin typeface="Segoe UI Semibold" pitchFamily="34" charset="0"/>
                 <a:ea typeface="Segoe UI Semibold" pitchFamily="34" charset="-122"/>
                 <a:cs typeface="Segoe UI Semibold" pitchFamily="34" charset="-120"/>
               </a:rPr>
-              <a:t>Two questions before we build</a:t>
-            </a:r>
-            <a:endParaRPr lang="en-US" sz="2400" dirty="0"/>
-          </a:p>
-        </p:txBody>
-      </p:sp>
-      <p:sp>
-        <p:nvSpPr>
-          <p:cNvPr id="4" name="Shape 2"/>
-          <p:cNvSpPr/>
-          <p:nvPr/>
-        </p:nvSpPr>
-        <p:spPr>
-          <a:xfrm>
-            <a:off x="609600" y="3024378"/>
-            <a:ext cx="10972800" cy="797814"/>
-          </a:xfrm>
-          <a:prstGeom prst="roundRect">
-            <a:avLst>
-              <a:gd name="adj" fmla="val 13754"/>
-            </a:avLst>
-          </a:prstGeom>
-          <a:solidFill>
-            <a:srgbClr val="FFFFFF"/>
-          </a:solidFill>
-          <a:ln w="9525">
-            <a:solidFill>
-              <a:srgbClr val="E2E8F0"/>
-            </a:solidFill>
-            <a:prstDash val="solid"/>
-          </a:ln>
-        </p:spPr>
-      </p:sp>
-      <p:sp>
-        <p:nvSpPr>
-          <p:cNvPr id="5" name="Text 3"/>
-          <p:cNvSpPr/>
-          <p:nvPr/>
-        </p:nvSpPr>
-        <p:spPr>
-          <a:xfrm>
-            <a:off x="847344" y="3024378"/>
-            <a:ext cx="502920" cy="797814"/>
-          </a:xfrm>
-          <a:prstGeom prst="rect">
-            <a:avLst/>
-          </a:prstGeom>
-          <a:noFill/>
-          <a:ln/>
-        </p:spPr>
-        <p:txBody>
-          <a:bodyPr wrap="square" lIns="0" tIns="0" rIns="0" bIns="0" rtlCol="0" anchor="ctr"/>
-          <a:lstStyle/>
-          <a:p>
-            <a:pPr algn="l" indent="0" marL="0">
-              <a:lnSpc>
-                <a:spcPct val="115000"/>
-              </a:lnSpc>
-              <a:buNone/>
-            </a:pPr>
-            <a:r>
-              <a:rPr lang="en-US" sz="1500" dirty="0">
-                <a:solidFill>
-                  <a:srgbClr val="0284C7"/>
-                </a:solidFill>
-                <a:latin typeface="Segoe UI Semibold" pitchFamily="34" charset="0"/>
-                <a:ea typeface="Segoe UI Semibold" pitchFamily="34" charset="-122"/>
-                <a:cs typeface="Segoe UI Semibold" pitchFamily="34" charset="-120"/>
-              </a:rPr>
-              <a:t>01</a:t>
-            </a:r>
-            <a:endParaRPr lang="en-US" sz="1500" dirty="0"/>
-          </a:p>
-        </p:txBody>
-      </p:sp>
-      <p:sp>
-        <p:nvSpPr>
-          <p:cNvPr id="6" name="Text 4"/>
-          <p:cNvSpPr/>
-          <p:nvPr/>
-        </p:nvSpPr>
-        <p:spPr>
-          <a:xfrm>
-            <a:off x="1341120" y="3207258"/>
-            <a:ext cx="10003536" cy="205740"/>
+              <a:t>Q&amp;A</a:t>
+            </a:r>
+            <a:endParaRPr lang="en-US" sz="3300" dirty="0"/>
+          </a:p>
+        </p:txBody>
+      </p:sp>
+      <p:sp>
+        <p:nvSpPr>
+          <p:cNvPr id="4" name="Text 2"/>
+          <p:cNvSpPr/>
+          <p:nvPr/>
+        </p:nvSpPr>
+        <p:spPr>
+          <a:xfrm>
+            <a:off x="758952" y="3707130"/>
+            <a:ext cx="7315200" cy="428625"/>
           </a:xfrm>
           <a:prstGeom prst="rect">
             <a:avLst/>
@@ -7183,217 +6602,22 @@
           <a:p>
             <a:pPr algn="l" indent="0" marL="0">
               <a:lnSpc>
-                <a:spcPct val="110000"/>
-              </a:lnSpc>
-              <a:buNone/>
-            </a:pPr>
-            <a:r>
-              <a:rPr lang="en-US" sz="1350" b="1" dirty="0">
-                <a:solidFill>
-                  <a:srgbClr val="0F172A"/>
+                <a:spcPct val="120000"/>
+              </a:lnSpc>
+              <a:buNone/>
+            </a:pPr>
+            <a:r>
+              <a:rPr lang="en-US" sz="1350" dirty="0">
+                <a:solidFill>
+                  <a:srgbClr val="94A3B8"/>
                 </a:solidFill>
                 <a:latin typeface="Segoe UI" pitchFamily="34" charset="0"/>
                 <a:ea typeface="Segoe UI" pitchFamily="34" charset="-122"/>
                 <a:cs typeface="Segoe UI" pitchFamily="34" charset="-120"/>
               </a:rPr>
-              <a:t>Is LOE / lab 1 / LOE_DB the only Oracle database?</a:t>
+              <a:t>Patient sync source does not change. The strip runs again once the Oracle flag can be read.</a:t>
             </a:r>
             <a:endParaRPr lang="en-US" sz="1350" dirty="0"/>
-          </a:p>
-        </p:txBody>
-      </p:sp>
-      <p:sp>
-        <p:nvSpPr>
-          <p:cNvPr id="7" name="Text 5"/>
-          <p:cNvSpPr/>
-          <p:nvPr/>
-        </p:nvSpPr>
-        <p:spPr>
-          <a:xfrm>
-            <a:off x="1341120" y="3467862"/>
-            <a:ext cx="10003536" cy="171450"/>
-          </a:xfrm>
-          <a:prstGeom prst="rect">
-            <a:avLst/>
-          </a:prstGeom>
-          <a:noFill/>
-          <a:ln/>
-        </p:spPr>
-        <p:txBody>
-          <a:bodyPr wrap="square" lIns="0" tIns="0" rIns="0" bIns="0" rtlCol="0" anchor="t"/>
-          <a:lstStyle/>
-          <a:p>
-            <a:pPr algn="l" indent="0" marL="0">
-              <a:lnSpc>
-                <a:spcPct val="110000"/>
-              </a:lnSpc>
-              <a:buNone/>
-            </a:pPr>
-            <a:r>
-              <a:rPr lang="en-US" sz="1125" dirty="0">
-                <a:solidFill>
-                  <a:srgbClr val="64748B"/>
-                </a:solidFill>
-                <a:latin typeface="Segoe UI" pitchFamily="34" charset="0"/>
-                <a:ea typeface="Segoe UI" pitchFamily="34" charset="-122"/>
-                <a:cs typeface="Segoe UI" pitchFamily="34" charset="-120"/>
-              </a:rPr>
-              <a:t>The flag read will use that connection unless the thread is already on Oracle.</a:t>
-            </a:r>
-            <a:endParaRPr lang="en-US" sz="1125" dirty="0"/>
-          </a:p>
-        </p:txBody>
-      </p:sp>
-      <p:sp>
-        <p:nvSpPr>
-          <p:cNvPr id="8" name="Shape 6"/>
-          <p:cNvSpPr/>
-          <p:nvPr/>
-        </p:nvSpPr>
-        <p:spPr>
-          <a:xfrm>
-            <a:off x="609600" y="3950208"/>
-            <a:ext cx="10972800" cy="797814"/>
-          </a:xfrm>
-          <a:prstGeom prst="roundRect">
-            <a:avLst>
-              <a:gd name="adj" fmla="val 13754"/>
-            </a:avLst>
-          </a:prstGeom>
-          <a:solidFill>
-            <a:srgbClr val="FFFFFF"/>
-          </a:solidFill>
-          <a:ln w="9525">
-            <a:solidFill>
-              <a:srgbClr val="E2E8F0"/>
-            </a:solidFill>
-            <a:prstDash val="solid"/>
-          </a:ln>
-        </p:spPr>
-      </p:sp>
-      <p:sp>
-        <p:nvSpPr>
-          <p:cNvPr id="9" name="Text 7"/>
-          <p:cNvSpPr/>
-          <p:nvPr/>
-        </p:nvSpPr>
-        <p:spPr>
-          <a:xfrm>
-            <a:off x="847344" y="3950208"/>
-            <a:ext cx="502920" cy="797814"/>
-          </a:xfrm>
-          <a:prstGeom prst="rect">
-            <a:avLst/>
-          </a:prstGeom>
-          <a:noFill/>
-          <a:ln/>
-        </p:spPr>
-        <p:txBody>
-          <a:bodyPr wrap="square" lIns="0" tIns="0" rIns="0" bIns="0" rtlCol="0" anchor="ctr"/>
-          <a:lstStyle/>
-          <a:p>
-            <a:pPr algn="l" indent="0" marL="0">
-              <a:lnSpc>
-                <a:spcPct val="115000"/>
-              </a:lnSpc>
-              <a:buNone/>
-            </a:pPr>
-            <a:r>
-              <a:rPr lang="en-US" sz="1500" dirty="0">
-                <a:solidFill>
-                  <a:srgbClr val="0284C7"/>
-                </a:solidFill>
-                <a:latin typeface="Segoe UI Semibold" pitchFamily="34" charset="0"/>
-                <a:ea typeface="Segoe UI Semibold" pitchFamily="34" charset="-122"/>
-                <a:cs typeface="Segoe UI Semibold" pitchFamily="34" charset="-120"/>
-              </a:rPr>
-              <a:t>02</a:t>
-            </a:r>
-            <a:endParaRPr lang="en-US" sz="1500" dirty="0"/>
-          </a:p>
-        </p:txBody>
-      </p:sp>
-      <p:sp>
-        <p:nvSpPr>
-          <p:cNvPr id="10" name="Text 8"/>
-          <p:cNvSpPr/>
-          <p:nvPr/>
-        </p:nvSpPr>
-        <p:spPr>
-          <a:xfrm>
-            <a:off x="1341120" y="4133088"/>
-            <a:ext cx="10003536" cy="205740"/>
-          </a:xfrm>
-          <a:prstGeom prst="rect">
-            <a:avLst/>
-          </a:prstGeom>
-          <a:noFill/>
-          <a:ln/>
-        </p:spPr>
-        <p:txBody>
-          <a:bodyPr wrap="square" lIns="0" tIns="0" rIns="0" bIns="0" rtlCol="0" anchor="t"/>
-          <a:lstStyle/>
-          <a:p>
-            <a:pPr algn="l" indent="0" marL="0">
-              <a:lnSpc>
-                <a:spcPct val="110000"/>
-              </a:lnSpc>
-              <a:buNone/>
-            </a:pPr>
-            <a:r>
-              <a:rPr lang="en-US" sz="1350" b="1" dirty="0">
-                <a:solidFill>
-                  <a:srgbClr val="0F172A"/>
-                </a:solidFill>
-                <a:latin typeface="Segoe UI" pitchFamily="34" charset="0"/>
-                <a:ea typeface="Segoe UI" pitchFamily="34" charset="-122"/>
-                <a:cs typeface="Segoe UI" pitchFamily="34" charset="-120"/>
-              </a:rPr>
-              <a:t>If a distributed transaction is already open, may this Oracle read join it?</a:t>
-            </a:r>
-            <a:endParaRPr lang="en-US" sz="1350" dirty="0"/>
-          </a:p>
-        </p:txBody>
-      </p:sp>
-      <p:sp>
-        <p:nvSpPr>
-          <p:cNvPr id="11" name="Text 9"/>
-          <p:cNvSpPr/>
-          <p:nvPr/>
-        </p:nvSpPr>
-        <p:spPr>
-          <a:xfrm>
-            <a:off x="1341120" y="4393692"/>
-            <a:ext cx="10003536" cy="171450"/>
-          </a:xfrm>
-          <a:prstGeom prst="rect">
-            <a:avLst/>
-          </a:prstGeom>
-          <a:noFill/>
-          <a:ln/>
-        </p:spPr>
-        <p:txBody>
-          <a:bodyPr wrap="square" lIns="0" tIns="0" rIns="0" bIns="0" rtlCol="0" anchor="t"/>
-          <a:lstStyle/>
-          <a:p>
-            <a:pPr algn="l" indent="0" marL="0">
-              <a:lnSpc>
-                <a:spcPct val="110000"/>
-              </a:lnSpc>
-              <a:buNone/>
-            </a:pPr>
-            <a:r>
-              <a:rPr lang="en-US" sz="1125" dirty="0">
-                <a:solidFill>
-                  <a:srgbClr val="64748B"/>
-                </a:solidFill>
-                <a:latin typeface="Segoe UI" pitchFamily="34" charset="0"/>
-                <a:ea typeface="Segoe UI" pitchFamily="34" charset="-122"/>
-                <a:cs typeface="Segoe UI" pitchFamily="34" charset="-120"/>
-              </a:rPr>
-              <a:t>Hospital work will not be committed early. Transaction locking otherwise stays as LIS-10723 left it.</a:t>
-            </a:r>
-            <a:endParaRPr lang="en-US" sz="1125" dirty="0"/>
           </a:p>
         </p:txBody>
       </p:sp>
@@ -7431,14 +6655,63 @@
       </p:grpSpPr>
       <p:sp>
         <p:nvSpPr>
-          <p:cNvPr id="2" name="Text 0"/>
-          <p:cNvSpPr/>
-          <p:nvPr/>
-        </p:nvSpPr>
-        <p:spPr>
-          <a:xfrm>
-            <a:off x="758952" y="2722245"/>
-            <a:ext cx="9601200" cy="219456"/>
+          <p:cNvPr id="2" name="Shape 0"/>
+          <p:cNvSpPr/>
+          <p:nvPr/>
+        </p:nvSpPr>
+        <p:spPr>
+          <a:xfrm>
+            <a:off x="5867400" y="2052161"/>
+            <a:ext cx="457200" cy="457200"/>
+          </a:xfrm>
+          <a:prstGeom prst="ellipse">
+            <a:avLst/>
+          </a:prstGeom>
+          <a:solidFill>
+            <a:srgbClr val="082F49"/>
+          </a:solidFill>
+          <a:ln w="12700">
+            <a:solidFill>
+              <a:srgbClr val="082F49"/>
+            </a:solidFill>
+            <a:prstDash val="solid"/>
+          </a:ln>
+        </p:spPr>
+      </p:sp>
+      <p:pic>
+        <p:nvPicPr>
+          <p:cNvPr id="3" name="Image 0" descr="D:\Github\HA-Notes\LIS\skills\design-review-pptx\assets\icons\png\onDark\clipboard-check.png">    </p:cNvPr>
+          <p:cNvPicPr>
+            <a:picLocks noChangeAspect="1"/>
+          </p:cNvPicPr>
+          <p:nvPr/>
+        </p:nvPicPr>
+        <p:blipFill>
+          <a:blip r:embed="rId1"/>
+          <a:stretch>
+            <a:fillRect/>
+          </a:stretch>
+        </p:blipFill>
+        <p:spPr>
+          <a:xfrm>
+            <a:off x="5981700" y="2166461"/>
+            <a:ext cx="228600" cy="228600"/>
+          </a:xfrm>
+          <a:prstGeom prst="rect">
+            <a:avLst/>
+          </a:prstGeom>
+        </p:spPr>
+      </p:pic>
+      <p:sp>
+        <p:nvSpPr>
+          <p:cNvPr id="4" name="Text 1"/>
+          <p:cNvSpPr/>
+          <p:nvPr/>
+        </p:nvSpPr>
+        <p:spPr>
+          <a:xfrm>
+            <a:off x="1752600" y="2701385"/>
+            <a:ext cx="8686800" cy="481965"/>
           </a:xfrm>
           <a:prstGeom prst="rect">
             <a:avLst/>
@@ -7450,37 +6723,37 @@
           <a:bodyPr wrap="square" lIns="0" tIns="0" rIns="0" bIns="0" rtlCol="0" anchor="t"/>
           <a:lstStyle/>
           <a:p>
-            <a:pPr algn="l" indent="0" marL="0">
-              <a:lnSpc>
-                <a:spcPct val="115000"/>
-              </a:lnSpc>
-              <a:buNone/>
-            </a:pPr>
-            <a:r>
-              <a:rPr lang="en-US" sz="1050" spc="150" kern="0" dirty="0">
-                <a:solidFill>
-                  <a:srgbClr val="38BDF8"/>
+            <a:pPr algn="ctr" indent="0" marL="0">
+              <a:lnSpc>
+                <a:spcPct val="105000"/>
+              </a:lnSpc>
+              <a:buNone/>
+            </a:pPr>
+            <a:r>
+              <a:rPr lang="en-US" sz="3300" dirty="0">
+                <a:solidFill>
+                  <a:srgbClr val="FFFFFF"/>
                 </a:solidFill>
                 <a:latin typeface="Segoe UI Semibold" pitchFamily="34" charset="0"/>
                 <a:ea typeface="Segoe UI Semibold" pitchFamily="34" charset="-122"/>
                 <a:cs typeface="Segoe UI Semibold" pitchFamily="34" charset="-120"/>
               </a:rPr>
-              <a:t>DISCUSSION</a:t>
-            </a:r>
-            <a:endParaRPr lang="en-US" sz="1050" dirty="0"/>
-          </a:p>
-        </p:txBody>
-      </p:sp>
-      <p:sp>
-        <p:nvSpPr>
-          <p:cNvPr id="3" name="Text 1"/>
-          <p:cNvSpPr/>
-          <p:nvPr/>
-        </p:nvSpPr>
-        <p:spPr>
-          <a:xfrm>
-            <a:off x="758952" y="3069717"/>
-            <a:ext cx="9601200" cy="481965"/>
+              <a:t>Read the flag, then strip for Sybase</a:t>
+            </a:r>
+            <a:endParaRPr lang="en-US" sz="3300" dirty="0"/>
+          </a:p>
+        </p:txBody>
+      </p:sp>
+      <p:sp>
+        <p:nvSpPr>
+          <p:cNvPr id="5" name="Text 2"/>
+          <p:cNvSpPr/>
+          <p:nvPr/>
+        </p:nvSpPr>
+        <p:spPr>
+          <a:xfrm>
+            <a:off x="2406396" y="3338798"/>
+            <a:ext cx="7379208" cy="214313"/>
           </a:xfrm>
           <a:prstGeom prst="rect">
             <a:avLst/>
@@ -7492,49 +6765,7 @@
           <a:bodyPr wrap="square" lIns="0" tIns="0" rIns="0" bIns="0" rtlCol="0" anchor="t"/>
           <a:lstStyle/>
           <a:p>
-            <a:pPr algn="l" indent="0" marL="0">
-              <a:lnSpc>
-                <a:spcPct val="105000"/>
-              </a:lnSpc>
-              <a:buNone/>
-            </a:pPr>
-            <a:r>
-              <a:rPr lang="en-US" sz="3300" dirty="0">
-                <a:solidFill>
-                  <a:srgbClr val="FFFFFF"/>
-                </a:solidFill>
-                <a:latin typeface="Segoe UI Semibold" pitchFamily="34" charset="0"/>
-                <a:ea typeface="Segoe UI Semibold" pitchFamily="34" charset="-122"/>
-                <a:cs typeface="Segoe UI Semibold" pitchFamily="34" charset="-120"/>
-              </a:rPr>
-              <a:t>Q&amp;A</a:t>
-            </a:r>
-            <a:endParaRPr lang="en-US" sz="3300" dirty="0"/>
-          </a:p>
-        </p:txBody>
-      </p:sp>
-      <p:sp>
-        <p:nvSpPr>
-          <p:cNvPr id="4" name="Text 2"/>
-          <p:cNvSpPr/>
-          <p:nvPr/>
-        </p:nvSpPr>
-        <p:spPr>
-          <a:xfrm>
-            <a:off x="758952" y="3707130"/>
-            <a:ext cx="7315200" cy="428625"/>
-          </a:xfrm>
-          <a:prstGeom prst="rect">
-            <a:avLst/>
-          </a:prstGeom>
-          <a:noFill/>
-          <a:ln/>
-        </p:spPr>
-        <p:txBody>
-          <a:bodyPr wrap="square" lIns="0" tIns="0" rIns="0" bIns="0" rtlCol="0" anchor="t"/>
-          <a:lstStyle/>
-          <a:p>
-            <a:pPr algn="l" indent="0" marL="0">
+            <a:pPr algn="ctr" indent="0" marL="0">
               <a:lnSpc>
                 <a:spcPct val="120000"/>
               </a:lnSpc>
@@ -7549,9 +6780,261 @@
                 <a:ea typeface="Segoe UI" pitchFamily="34" charset="-122"/>
                 <a:cs typeface="Segoe UI" pitchFamily="34" charset="-120"/>
               </a:rPr>
-              <a:t>Patient sync source does not change. The strip runs again once the Oracle flag can be read.</a:t>
+              <a:t>No schema change. No config change.</a:t>
             </a:r>
             <a:endParaRPr lang="en-US" sz="1350" dirty="0"/>
+          </a:p>
+        </p:txBody>
+      </p:sp>
+      <p:sp>
+        <p:nvSpPr>
+          <p:cNvPr id="6" name="Text 3"/>
+          <p:cNvSpPr/>
+          <p:nvPr/>
+        </p:nvSpPr>
+        <p:spPr>
+          <a:xfrm>
+            <a:off x="2548128" y="3937159"/>
+            <a:ext cx="3291840" cy="182880"/>
+          </a:xfrm>
+          <a:prstGeom prst="rect">
+            <a:avLst/>
+          </a:prstGeom>
+          <a:noFill/>
+          <a:ln/>
+        </p:spPr>
+        <p:txBody>
+          <a:bodyPr wrap="square" lIns="0" tIns="0" rIns="0" bIns="0" rtlCol="0" anchor="t"/>
+          <a:lstStyle/>
+          <a:p>
+            <a:pPr algn="l" indent="0" marL="0">
+              <a:lnSpc>
+                <a:spcPct val="115000"/>
+              </a:lnSpc>
+              <a:buNone/>
+            </a:pPr>
+            <a:r>
+              <a:rPr lang="en-US" sz="1050" dirty="0">
+                <a:solidFill>
+                  <a:srgbClr val="64748B"/>
+                </a:solidFill>
+                <a:latin typeface="Segoe UI" pitchFamily="34" charset="0"/>
+                <a:ea typeface="Segoe UI" pitchFamily="34" charset="-122"/>
+                <a:cs typeface="Segoe UI" pitchFamily="34" charset="-120"/>
+              </a:rPr>
+              <a:t>AFTER CP3</a:t>
+            </a:r>
+            <a:endParaRPr lang="en-US" sz="1050" dirty="0"/>
+          </a:p>
+        </p:txBody>
+      </p:sp>
+      <p:sp>
+        <p:nvSpPr>
+          <p:cNvPr id="7" name="Text 4"/>
+          <p:cNvSpPr/>
+          <p:nvPr/>
+        </p:nvSpPr>
+        <p:spPr>
+          <a:xfrm>
+            <a:off x="2548128" y="4156615"/>
+            <a:ext cx="3291840" cy="640080"/>
+          </a:xfrm>
+          <a:prstGeom prst="rect">
+            <a:avLst/>
+          </a:prstGeom>
+          <a:noFill/>
+          <a:ln/>
+        </p:spPr>
+        <p:txBody>
+          <a:bodyPr wrap="square" lIns="0" tIns="0" rIns="0" bIns="0" rtlCol="0" anchor="t"/>
+          <a:lstStyle/>
+          <a:p>
+            <a:pPr algn="l" indent="0" marL="0">
+              <a:lnSpc>
+                <a:spcPct val="115000"/>
+              </a:lnSpc>
+              <a:buNone/>
+            </a:pPr>
+            <a:r>
+              <a:rPr lang="en-US" sz="1200" dirty="0">
+                <a:solidFill>
+                  <a:srgbClr val="F1F5F9"/>
+                </a:solidFill>
+                <a:latin typeface="Segoe UI" pitchFamily="34" charset="0"/>
+                <a:ea typeface="Segoe UI" pitchFamily="34" charset="-122"/>
+                <a:cs typeface="Segoe UI" pitchFamily="34" charset="-120"/>
+              </a:rPr>
+              <a:t>Write actions back onto the design note</a:t>
+            </a:r>
+            <a:endParaRPr lang="en-US" sz="1200" dirty="0"/>
+          </a:p>
+        </p:txBody>
+      </p:sp>
+      <p:sp>
+        <p:nvSpPr>
+          <p:cNvPr id="8" name="Shape 5"/>
+          <p:cNvSpPr/>
+          <p:nvPr/>
+        </p:nvSpPr>
+        <p:spPr>
+          <a:xfrm>
+            <a:off x="6096000" y="3937159"/>
+            <a:ext cx="10973" cy="566928"/>
+          </a:xfrm>
+          <a:prstGeom prst="rect">
+            <a:avLst/>
+          </a:prstGeom>
+          <a:solidFill>
+            <a:srgbClr val="1E293B"/>
+          </a:solidFill>
+          <a:ln w="12700">
+            <a:solidFill>
+              <a:srgbClr val="1E293B"/>
+            </a:solidFill>
+            <a:prstDash val="solid"/>
+          </a:ln>
+        </p:spPr>
+      </p:sp>
+      <p:sp>
+        <p:nvSpPr>
+          <p:cNvPr id="9" name="Text 6"/>
+          <p:cNvSpPr/>
+          <p:nvPr/>
+        </p:nvSpPr>
+        <p:spPr>
+          <a:xfrm>
+            <a:off x="6352032" y="3937159"/>
+            <a:ext cx="3291840" cy="182880"/>
+          </a:xfrm>
+          <a:prstGeom prst="rect">
+            <a:avLst/>
+          </a:prstGeom>
+          <a:noFill/>
+          <a:ln/>
+        </p:spPr>
+        <p:txBody>
+          <a:bodyPr wrap="square" lIns="0" tIns="0" rIns="0" bIns="0" rtlCol="0" anchor="t"/>
+          <a:lstStyle/>
+          <a:p>
+            <a:pPr algn="l" indent="0" marL="0">
+              <a:lnSpc>
+                <a:spcPct val="115000"/>
+              </a:lnSpc>
+              <a:buNone/>
+            </a:pPr>
+            <a:r>
+              <a:rPr lang="en-US" sz="1050" dirty="0">
+                <a:solidFill>
+                  <a:srgbClr val="64748B"/>
+                </a:solidFill>
+                <a:latin typeface="Segoe UI" pitchFamily="34" charset="0"/>
+                <a:ea typeface="Segoe UI" pitchFamily="34" charset="-122"/>
+                <a:cs typeface="Segoe UI" pitchFamily="34" charset="-120"/>
+              </a:rPr>
+              <a:t>THEN BUILD</a:t>
+            </a:r>
+            <a:endParaRPr lang="en-US" sz="1050" dirty="0"/>
+          </a:p>
+        </p:txBody>
+      </p:sp>
+      <p:sp>
+        <p:nvSpPr>
+          <p:cNvPr id="10" name="Text 7"/>
+          <p:cNvSpPr/>
+          <p:nvPr/>
+        </p:nvSpPr>
+        <p:spPr>
+          <a:xfrm>
+            <a:off x="6352032" y="4156615"/>
+            <a:ext cx="3291840" cy="640080"/>
+          </a:xfrm>
+          <a:prstGeom prst="rect">
+            <a:avLst/>
+          </a:prstGeom>
+          <a:noFill/>
+          <a:ln/>
+        </p:spPr>
+        <p:txBody>
+          <a:bodyPr wrap="square" lIns="0" tIns="0" rIns="0" bIns="0" rtlCol="0" anchor="t"/>
+          <a:lstStyle/>
+          <a:p>
+            <a:pPr algn="l" indent="0" marL="0">
+              <a:lnSpc>
+                <a:spcPct val="115000"/>
+              </a:lnSpc>
+              <a:buNone/>
+            </a:pPr>
+            <a:r>
+              <a:rPr lang="en-US" sz="1200" dirty="0">
+                <a:solidFill>
+                  <a:srgbClr val="F1F5F9"/>
+                </a:solidFill>
+                <a:latin typeface="Segoe UI" pitchFamily="34" charset="0"/>
+                <a:ea typeface="Segoe UI" pitchFamily="34" charset="-122"/>
+                <a:cs typeface="Segoe UI" pitchFamily="34" charset="-120"/>
+              </a:rPr>
+              <a:t>data-source only</a:t>
+            </a:r>
+            <a:endParaRPr lang="en-US" sz="1200" dirty="0"/>
+          </a:p>
+        </p:txBody>
+      </p:sp>
+      <p:sp>
+        <p:nvSpPr>
+          <p:cNvPr id="11" name="Text 8"/>
+          <p:cNvSpPr/>
+          <p:nvPr/>
+        </p:nvSpPr>
+        <p:spPr>
+          <a:xfrm>
+            <a:off x="758952" y="6089904"/>
+            <a:ext cx="10674096" cy="237744"/>
+          </a:xfrm>
+          <a:prstGeom prst="rect">
+            <a:avLst/>
+          </a:prstGeom>
+          <a:noFill/>
+          <a:ln/>
+        </p:spPr>
+        <p:txBody>
+          <a:bodyPr wrap="square" lIns="0" tIns="0" rIns="0" bIns="0" rtlCol="0" anchor="t"/>
+          <a:lstStyle/>
+          <a:p>
+            <a:pPr algn="ctr" indent="0" marL="0">
+              <a:lnSpc>
+                <a:spcPct val="120000"/>
+              </a:lnSpc>
+              <a:buNone/>
+            </a:pPr>
+            <a:r>
+              <a:rPr lang="en-US" sz="1125" dirty="0">
+                <a:solidFill>
+                  <a:srgbClr val="38BDF8"/>
+                </a:solidFill>
+                <a:latin typeface="Consolas" pitchFamily="34" charset="0"/>
+                <a:ea typeface="Consolas" pitchFamily="34" charset="-122"/>
+                <a:cs typeface="Consolas" pitchFamily="34" charset="-120"/>
+              </a:rPr>
+              <a:t>TMP-oracle-route-lookup   </a:t>
+            </a:r>
+            <a:pPr algn="ctr" indent="0" marL="0">
+              <a:lnSpc>
+                <a:spcPct val="120000"/>
+              </a:lnSpc>
+              <a:buNone/>
+            </a:pPr>
+            <a:r>
+              <a:rPr lang="en-US" sz="1125" dirty="0">
+                <a:solidFill>
+                  <a:srgbClr val="64748B"/>
+                </a:solidFill>
+                <a:latin typeface="Segoe UI" pitchFamily="34" charset="0"/>
+                <a:ea typeface="Segoe UI" pitchFamily="34" charset="-122"/>
+                <a:cs typeface="Segoe UI" pitchFamily="34" charset="-120"/>
+              </a:rPr>
+              <a:t>lis-patient-pmi-sync-svc  ·  LIS-10723</a:t>
+            </a:r>
+            <a:endParaRPr lang="en-US" sz="1125" dirty="0"/>
           </a:p>
         </p:txBody>
       </p:sp>

</xml_diff>

<commit_message>
vault backup: 2026-09-25 14:29:28
</commit_message>
<xml_diff>
--- a/SDLC/Projects/TMP-oracle-route-lookup — Oracle route lookup/assets/Oracle route lookup.pptx
+++ b/SDLC/Projects/TMP-oracle-route-lookup — Oracle route lookup/assets/Oracle route lookup.pptx
@@ -12,11 +12,9 @@
     <p:sldId id="260" r:id="rId6"/>
     <p:sldId id="261" r:id="rId7"/>
     <p:sldId id="262" r:id="rId8"/>
-    <p:sldId id="263" r:id="rId9"/>
-    <p:sldId id="264" r:id="rId10"/>
   </p:sldIdLst>
   <p:notesMasterIdLst>
-    <p:notesMasterId r:id="rId11"/>
+    <p:notesMasterId r:id="rId9"/>
   </p:notesMasterIdLst>
   <p:sldSz cx="12192000" cy="6858000"/>
   <p:notesSz cx="6858000" cy="12192000"/>
@@ -1038,7 +1036,7 @@
           <a:p>
             <a:r>
               <a:rPr lang="en-US" dirty="0"/>
-              <a:t>The first question is whether a second Oracle database is registered. The second is enlistment only. We are not redesigning transaction locking.</a:t>
+              <a:t>Likely question: does patient sync source change? No. The strip is already there. It runs again once the Oracle flag can be read.</a:t>
             </a:r>
             <a:endParaRPr lang="en-US" dirty="0"/>
           </a:p>
@@ -1062,182 +1060,6 @@
             <a:fld id="{F7021451-1387-4CA6-816F-3879F97B5CBC}" type="slidenum">
               <a:rPr lang="en-US"/>
               <a:t>7</a:t>
-            </a:fld>
-            <a:endParaRPr lang="en-US"/>
-          </a:p>
-        </p:txBody>
-      </p:sp>
-    </p:spTree>
-    <p:extLst>
-      <p:ext uri="{BB962C8B-B14F-4D97-AF65-F5344CB8AC3E}">
-        <p14:creationId xmlns:p14="http://schemas.microsoft.com/office/powerpoint/2010/main" val="1024086991"/>
-      </p:ext>
-    </p:extLst>
-  </p:cSld>
-  <p:clrMapOvr>
-    <a:masterClrMapping/>
-  </p:clrMapOvr>
-</p:notes>
-</file>
-
-<file path=ppt/notesSlides/notesSlide8.xml><?xml version="1.0" encoding="utf-8"?>
-<p:notes xmlns:a="http://schemas.openxmlformats.org/drawingml/2006/main" xmlns:r="http://schemas.openxmlformats.org/officeDocument/2006/relationships" xmlns:p="http://schemas.openxmlformats.org/presentationml/2006/main">
-  <p:cSld>
-    <p:spTree>
-      <p:nvGrpSpPr>
-        <p:cNvPr id="1" name=""/>
-        <p:cNvGrpSpPr/>
-        <p:nvPr/>
-      </p:nvGrpSpPr>
-      <p:grpSpPr>
-        <a:xfrm>
-          <a:off x="0" y="0"/>
-          <a:ext cx="0" cy="0"/>
-          <a:chOff x="0" y="0"/>
-          <a:chExt cx="0" cy="0"/>
-        </a:xfrm>
-      </p:grpSpPr>
-      <p:sp>
-        <p:nvSpPr>
-          <p:cNvPr id="2" name="Slide Image Placeholder 1"/>
-          <p:cNvSpPr>
-            <a:spLocks noGrp="1" noRot="1" noChangeAspect="1"/>
-          </p:cNvSpPr>
-          <p:nvPr>
-            <p:ph type="sldImg"/>
-          </p:nvPr>
-        </p:nvSpPr>
-        <p:spPr/>
-      </p:sp>
-      <p:sp>
-        <p:nvSpPr>
-          <p:cNvPr id="3" name="Notes Placeholder 2"/>
-          <p:cNvSpPr>
-            <a:spLocks noGrp="1"/>
-          </p:cNvSpPr>
-          <p:nvPr>
-            <p:ph type="body" idx="1"/>
-          </p:nvPr>
-        </p:nvSpPr>
-        <p:spPr/>
-        <p:txBody>
-          <a:bodyPr/>
-          <a:lstStyle/>
-          <a:p>
-            <a:r>
-              <a:rPr lang="en-US" dirty="0"/>
-              <a:t>Likely question: does patient sync source change? No. The strip is already there. It runs again once the Oracle flag can be read.</a:t>
-            </a:r>
-            <a:endParaRPr lang="en-US" dirty="0"/>
-          </a:p>
-        </p:txBody>
-      </p:sp>
-      <p:sp>
-        <p:nvSpPr>
-          <p:cNvPr id="4" name="Slide Number Placeholder 3"/>
-          <p:cNvSpPr>
-            <a:spLocks noGrp="1"/>
-          </p:cNvSpPr>
-          <p:nvPr>
-            <p:ph type="sldNum" sz="quarter" idx="10"/>
-          </p:nvPr>
-        </p:nvSpPr>
-        <p:spPr/>
-        <p:txBody>
-          <a:bodyPr/>
-          <a:lstStyle/>
-          <a:p>
-            <a:fld id="{F7021451-1387-4CA6-816F-3879F97B5CBC}" type="slidenum">
-              <a:rPr lang="en-US"/>
-              <a:t>8</a:t>
-            </a:fld>
-            <a:endParaRPr lang="en-US"/>
-          </a:p>
-        </p:txBody>
-      </p:sp>
-    </p:spTree>
-    <p:extLst>
-      <p:ext uri="{BB962C8B-B14F-4D97-AF65-F5344CB8AC3E}">
-        <p14:creationId xmlns:p14="http://schemas.microsoft.com/office/powerpoint/2010/main" val="1024086991"/>
-      </p:ext>
-    </p:extLst>
-  </p:cSld>
-  <p:clrMapOvr>
-    <a:masterClrMapping/>
-  </p:clrMapOvr>
-</p:notes>
-</file>
-
-<file path=ppt/notesSlides/notesSlide9.xml><?xml version="1.0" encoding="utf-8"?>
-<p:notes xmlns:a="http://schemas.openxmlformats.org/drawingml/2006/main" xmlns:r="http://schemas.openxmlformats.org/officeDocument/2006/relationships" xmlns:p="http://schemas.openxmlformats.org/presentationml/2006/main">
-  <p:cSld>
-    <p:spTree>
-      <p:nvGrpSpPr>
-        <p:cNvPr id="1" name=""/>
-        <p:cNvGrpSpPr/>
-        <p:nvPr/>
-      </p:nvGrpSpPr>
-      <p:grpSpPr>
-        <a:xfrm>
-          <a:off x="0" y="0"/>
-          <a:ext cx="0" cy="0"/>
-          <a:chOff x="0" y="0"/>
-          <a:chExt cx="0" cy="0"/>
-        </a:xfrm>
-      </p:grpSpPr>
-      <p:sp>
-        <p:nvSpPr>
-          <p:cNvPr id="2" name="Slide Image Placeholder 1"/>
-          <p:cNvSpPr>
-            <a:spLocks noGrp="1" noRot="1" noChangeAspect="1"/>
-          </p:cNvSpPr>
-          <p:nvPr>
-            <p:ph type="sldImg"/>
-          </p:nvPr>
-        </p:nvSpPr>
-        <p:spPr/>
-      </p:sp>
-      <p:sp>
-        <p:nvSpPr>
-          <p:cNvPr id="3" name="Notes Placeholder 2"/>
-          <p:cNvSpPr>
-            <a:spLocks noGrp="1"/>
-          </p:cNvSpPr>
-          <p:nvPr>
-            <p:ph type="body" idx="1"/>
-          </p:nvPr>
-        </p:nvSpPr>
-        <p:spPr/>
-        <p:txBody>
-          <a:bodyPr/>
-          <a:lstStyle/>
-          <a:p>
-            <a:r>
-              <a:rPr lang="en-US" dirty="0"/>
-              <a:t>After the room, write any CP3 actions back onto the design note. This deck does not close the review gate.</a:t>
-            </a:r>
-            <a:endParaRPr lang="en-US" dirty="0"/>
-          </a:p>
-        </p:txBody>
-      </p:sp>
-      <p:sp>
-        <p:nvSpPr>
-          <p:cNvPr id="4" name="Slide Number Placeholder 3"/>
-          <p:cNvSpPr>
-            <a:spLocks noGrp="1"/>
-          </p:cNvSpPr>
-          <p:nvPr>
-            <p:ph type="sldNum" sz="quarter" idx="10"/>
-          </p:nvPr>
-        </p:nvSpPr>
-        <p:spPr/>
-        <p:txBody>
-          <a:bodyPr/>
-          <a:lstStyle/>
-          <a:p>
-            <a:fld id="{F7021451-1387-4CA6-816F-3879F97B5CBC}" type="slidenum">
-              <a:rPr lang="en-US"/>
-              <a:t>9</a:t>
             </a:fld>
             <a:endParaRPr lang="en-US"/>
           </a:p>
@@ -5347,12 +5169,12 @@
         </p:nvSpPr>
         <p:spPr>
           <a:xfrm>
-            <a:off x="609600" y="2783777"/>
-            <a:ext cx="5335524" cy="2204847"/>
+            <a:off x="609600" y="2873073"/>
+            <a:ext cx="5335524" cy="2026253"/>
           </a:xfrm>
           <a:prstGeom prst="roundRect">
             <a:avLst>
-              <a:gd name="adj" fmla="val 4977"/>
+              <a:gd name="adj" fmla="val 5415"/>
             </a:avLst>
           </a:prstGeom>
           <a:solidFill>
@@ -5382,7 +5204,7 @@
         </p:blipFill>
         <p:spPr>
           <a:xfrm>
-            <a:off x="883920" y="3090101"/>
+            <a:off x="883920" y="3179397"/>
             <a:ext cx="265176" cy="265176"/>
           </a:xfrm>
           <a:prstGeom prst="rect">
@@ -5398,7 +5220,7 @@
         </p:nvSpPr>
         <p:spPr>
           <a:xfrm>
-            <a:off x="1249680" y="3076385"/>
+            <a:off x="1249680" y="3165681"/>
             <a:ext cx="4421124" cy="292608"/>
           </a:xfrm>
           <a:prstGeom prst="rect">
@@ -5440,7 +5262,7 @@
         </p:nvSpPr>
         <p:spPr>
           <a:xfrm>
-            <a:off x="883920" y="3506153"/>
+            <a:off x="883920" y="3595449"/>
             <a:ext cx="228600" cy="228600"/>
           </a:xfrm>
           <a:prstGeom prst="ellipse">
@@ -5485,7 +5307,7 @@
         </p:nvSpPr>
         <p:spPr>
           <a:xfrm>
-            <a:off x="1222248" y="3533585"/>
+            <a:off x="1222248" y="3622881"/>
             <a:ext cx="4448556" cy="196882"/>
           </a:xfrm>
           <a:prstGeom prst="rect">
@@ -5527,7 +5349,7 @@
         </p:nvSpPr>
         <p:spPr>
           <a:xfrm>
-            <a:off x="883920" y="3840194"/>
+            <a:off x="883920" y="3929491"/>
             <a:ext cx="228600" cy="228600"/>
           </a:xfrm>
           <a:prstGeom prst="ellipse">
@@ -5572,7 +5394,7 @@
         </p:nvSpPr>
         <p:spPr>
           <a:xfrm>
-            <a:off x="1222248" y="3867626"/>
+            <a:off x="1222248" y="3956923"/>
             <a:ext cx="4448556" cy="196882"/>
           </a:xfrm>
           <a:prstGeom prst="rect">
@@ -5614,7 +5436,7 @@
         </p:nvSpPr>
         <p:spPr>
           <a:xfrm>
-            <a:off x="883920" y="4174236"/>
+            <a:off x="883920" y="4263533"/>
             <a:ext cx="228600" cy="228600"/>
           </a:xfrm>
           <a:prstGeom prst="ellipse">
@@ -5659,7 +5481,7 @@
         </p:nvSpPr>
         <p:spPr>
           <a:xfrm>
-            <a:off x="1222248" y="4201668"/>
+            <a:off x="1222248" y="4290965"/>
             <a:ext cx="4448556" cy="196882"/>
           </a:xfrm>
           <a:prstGeom prst="rect">
@@ -5701,12 +5523,12 @@
         </p:nvSpPr>
         <p:spPr>
           <a:xfrm>
-            <a:off x="6246876" y="2783777"/>
-            <a:ext cx="5335524" cy="2204847"/>
+            <a:off x="6246876" y="2873073"/>
+            <a:ext cx="5335524" cy="2026253"/>
           </a:xfrm>
           <a:prstGeom prst="roundRect">
             <a:avLst>
-              <a:gd name="adj" fmla="val 4977"/>
+              <a:gd name="adj" fmla="val 5415"/>
             </a:avLst>
           </a:prstGeom>
           <a:solidFill>
@@ -5736,7 +5558,7 @@
         </p:blipFill>
         <p:spPr>
           <a:xfrm>
-            <a:off x="6521196" y="3090101"/>
+            <a:off x="6521196" y="3179397"/>
             <a:ext cx="265176" cy="265176"/>
           </a:xfrm>
           <a:prstGeom prst="rect">
@@ -5752,7 +5574,7 @@
         </p:nvSpPr>
         <p:spPr>
           <a:xfrm>
-            <a:off x="6886956" y="3076385"/>
+            <a:off x="6886956" y="3165681"/>
             <a:ext cx="4421124" cy="292608"/>
           </a:xfrm>
           <a:prstGeom prst="rect">
@@ -5794,7 +5616,7 @@
         </p:nvSpPr>
         <p:spPr>
           <a:xfrm>
-            <a:off x="6521196" y="3506153"/>
+            <a:off x="6521196" y="3595449"/>
             <a:ext cx="228600" cy="228600"/>
           </a:xfrm>
           <a:prstGeom prst="ellipse">
@@ -5839,7 +5661,7 @@
         </p:nvSpPr>
         <p:spPr>
           <a:xfrm>
-            <a:off x="6859524" y="3533585"/>
+            <a:off x="6859524" y="3622881"/>
             <a:ext cx="4448556" cy="196882"/>
           </a:xfrm>
           <a:prstGeom prst="rect">
@@ -5881,7 +5703,7 @@
         </p:nvSpPr>
         <p:spPr>
           <a:xfrm>
-            <a:off x="6521196" y="3840194"/>
+            <a:off x="6521196" y="3929491"/>
             <a:ext cx="228600" cy="228600"/>
           </a:xfrm>
           <a:prstGeom prst="ellipse">
@@ -5926,8 +5748,8 @@
         </p:nvSpPr>
         <p:spPr>
           <a:xfrm>
-            <a:off x="6859524" y="3867626"/>
-            <a:ext cx="4448556" cy="375476"/>
+            <a:off x="6859524" y="3956923"/>
+            <a:ext cx="4448556" cy="196882"/>
           </a:xfrm>
           <a:prstGeom prst="rect">
             <a:avLst/>
@@ -5954,7 +5776,7 @@
                 <a:ea typeface="Segoe UI" pitchFamily="34" charset="-122"/>
                 <a:cs typeface="Segoe UI" pitchFamily="34" charset="-120"/>
               </a:rPr>
-              <a:t>On a Sybase hospital, the log again says defaulting to PostgreSQL</a:t>
+              <a:t>On Sybase, the log says defaulting to PostgreSQL</a:t>
             </a:r>
             <a:endParaRPr lang="en-US" sz="1125" dirty="0"/>
           </a:p>
@@ -5968,7 +5790,7 @@
         </p:nvSpPr>
         <p:spPr>
           <a:xfrm>
-            <a:off x="6521196" y="4352830"/>
+            <a:off x="6521196" y="4263533"/>
             <a:ext cx="228600" cy="228600"/>
           </a:xfrm>
           <a:prstGeom prst="ellipse">
@@ -6013,7 +5835,7 @@
         </p:nvSpPr>
         <p:spPr>
           <a:xfrm>
-            <a:off x="6859524" y="4380262"/>
+            <a:off x="6859524" y="4290965"/>
             <a:ext cx="4448556" cy="196882"/>
           </a:xfrm>
           <a:prstGeom prst="rect">
@@ -6058,422 +5880,6 @@
 <file path=ppt/slides/slide7.xml><?xml version="1.0" encoding="utf-8"?>
 <p:sld xmlns:a="http://schemas.openxmlformats.org/drawingml/2006/main" xmlns:r="http://schemas.openxmlformats.org/officeDocument/2006/relationships" xmlns:p="http://schemas.openxmlformats.org/presentationml/2006/main">
   <p:cSld name="Slide 7">
-    <p:bg>
-      <p:bgPr>
-        <a:solidFill>
-          <a:srgbClr val="F8FAFC"/>
-        </a:solidFill>
-      </p:bgPr>
-    </p:bg>
-    <p:spTree>
-      <p:nvGrpSpPr>
-        <p:cNvPr id="1" name=""/>
-        <p:cNvGrpSpPr/>
-        <p:nvPr/>
-      </p:nvGrpSpPr>
-      <p:grpSpPr>
-        <a:xfrm>
-          <a:off x="0" y="0"/>
-          <a:ext cx="0" cy="0"/>
-          <a:chOff x="0" y="0"/>
-          <a:chExt cx="0" cy="0"/>
-        </a:xfrm>
-      </p:grpSpPr>
-      <p:sp>
-        <p:nvSpPr>
-          <p:cNvPr id="2" name="Text 0"/>
-          <p:cNvSpPr/>
-          <p:nvPr/>
-        </p:nvSpPr>
-        <p:spPr>
-          <a:xfrm>
-            <a:off x="609600" y="457200"/>
-            <a:ext cx="10972800" cy="228600"/>
-          </a:xfrm>
-          <a:prstGeom prst="rect">
-            <a:avLst/>
-          </a:prstGeom>
-          <a:noFill/>
-          <a:ln/>
-        </p:spPr>
-        <p:txBody>
-          <a:bodyPr wrap="square" lIns="0" tIns="0" rIns="0" bIns="0" rtlCol="0" anchor="ctr"/>
-          <a:lstStyle/>
-          <a:p>
-            <a:pPr indent="0" marL="0">
-              <a:buNone/>
-            </a:pPr>
-            <a:r>
-              <a:rPr lang="en-US" sz="1050" spc="150" kern="0" dirty="0">
-                <a:solidFill>
-                  <a:srgbClr val="0284C7"/>
-                </a:solidFill>
-                <a:latin typeface="Segoe UI Semibold" pitchFamily="34" charset="0"/>
-                <a:ea typeface="Segoe UI Semibold" pitchFamily="34" charset="-122"/>
-                <a:cs typeface="Segoe UI Semibold" pitchFamily="34" charset="-120"/>
-              </a:rPr>
-              <a:t>OPEN QUESTIONS</a:t>
-            </a:r>
-            <a:endParaRPr lang="en-US" sz="1050" dirty="0"/>
-          </a:p>
-        </p:txBody>
-      </p:sp>
-      <p:sp>
-        <p:nvSpPr>
-          <p:cNvPr id="3" name="Text 1"/>
-          <p:cNvSpPr/>
-          <p:nvPr/>
-        </p:nvSpPr>
-        <p:spPr>
-          <a:xfrm>
-            <a:off x="609600" y="722376"/>
-            <a:ext cx="10972800" cy="457200"/>
-          </a:xfrm>
-          <a:prstGeom prst="rect">
-            <a:avLst/>
-          </a:prstGeom>
-          <a:noFill/>
-          <a:ln/>
-        </p:spPr>
-        <p:txBody>
-          <a:bodyPr wrap="square" lIns="0" tIns="0" rIns="0" bIns="0" rtlCol="0" anchor="ctr"/>
-          <a:lstStyle/>
-          <a:p>
-            <a:pPr indent="0" marL="0">
-              <a:buNone/>
-            </a:pPr>
-            <a:r>
-              <a:rPr lang="en-US" sz="2400" dirty="0">
-                <a:solidFill>
-                  <a:srgbClr val="0F172A"/>
-                </a:solidFill>
-                <a:latin typeface="Segoe UI Semibold" pitchFamily="34" charset="0"/>
-                <a:ea typeface="Segoe UI Semibold" pitchFamily="34" charset="-122"/>
-                <a:cs typeface="Segoe UI Semibold" pitchFamily="34" charset="-120"/>
-              </a:rPr>
-              <a:t>Two questions before we build</a:t>
-            </a:r>
-            <a:endParaRPr lang="en-US" sz="2400" dirty="0"/>
-          </a:p>
-        </p:txBody>
-      </p:sp>
-      <p:sp>
-        <p:nvSpPr>
-          <p:cNvPr id="4" name="Shape 2"/>
-          <p:cNvSpPr/>
-          <p:nvPr/>
-        </p:nvSpPr>
-        <p:spPr>
-          <a:xfrm>
-            <a:off x="609600" y="3024378"/>
-            <a:ext cx="10972800" cy="797814"/>
-          </a:xfrm>
-          <a:prstGeom prst="roundRect">
-            <a:avLst>
-              <a:gd name="adj" fmla="val 13754"/>
-            </a:avLst>
-          </a:prstGeom>
-          <a:solidFill>
-            <a:srgbClr val="FFFFFF"/>
-          </a:solidFill>
-          <a:ln w="9525">
-            <a:solidFill>
-              <a:srgbClr val="E2E8F0"/>
-            </a:solidFill>
-            <a:prstDash val="solid"/>
-          </a:ln>
-        </p:spPr>
-      </p:sp>
-      <p:sp>
-        <p:nvSpPr>
-          <p:cNvPr id="5" name="Text 3"/>
-          <p:cNvSpPr/>
-          <p:nvPr/>
-        </p:nvSpPr>
-        <p:spPr>
-          <a:xfrm>
-            <a:off x="847344" y="3024378"/>
-            <a:ext cx="502920" cy="797814"/>
-          </a:xfrm>
-          <a:prstGeom prst="rect">
-            <a:avLst/>
-          </a:prstGeom>
-          <a:noFill/>
-          <a:ln/>
-        </p:spPr>
-        <p:txBody>
-          <a:bodyPr wrap="square" lIns="0" tIns="0" rIns="0" bIns="0" rtlCol="0" anchor="ctr"/>
-          <a:lstStyle/>
-          <a:p>
-            <a:pPr algn="l" indent="0" marL="0">
-              <a:lnSpc>
-                <a:spcPct val="115000"/>
-              </a:lnSpc>
-              <a:buNone/>
-            </a:pPr>
-            <a:r>
-              <a:rPr lang="en-US" sz="1500" dirty="0">
-                <a:solidFill>
-                  <a:srgbClr val="0284C7"/>
-                </a:solidFill>
-                <a:latin typeface="Segoe UI Semibold" pitchFamily="34" charset="0"/>
-                <a:ea typeface="Segoe UI Semibold" pitchFamily="34" charset="-122"/>
-                <a:cs typeface="Segoe UI Semibold" pitchFamily="34" charset="-120"/>
-              </a:rPr>
-              <a:t>01</a:t>
-            </a:r>
-            <a:endParaRPr lang="en-US" sz="1500" dirty="0"/>
-          </a:p>
-        </p:txBody>
-      </p:sp>
-      <p:sp>
-        <p:nvSpPr>
-          <p:cNvPr id="6" name="Text 4"/>
-          <p:cNvSpPr/>
-          <p:nvPr/>
-        </p:nvSpPr>
-        <p:spPr>
-          <a:xfrm>
-            <a:off x="1341120" y="3207258"/>
-            <a:ext cx="10003536" cy="205740"/>
-          </a:xfrm>
-          <a:prstGeom prst="rect">
-            <a:avLst/>
-          </a:prstGeom>
-          <a:noFill/>
-          <a:ln/>
-        </p:spPr>
-        <p:txBody>
-          <a:bodyPr wrap="square" lIns="0" tIns="0" rIns="0" bIns="0" rtlCol="0" anchor="t"/>
-          <a:lstStyle/>
-          <a:p>
-            <a:pPr algn="l" indent="0" marL="0">
-              <a:lnSpc>
-                <a:spcPct val="110000"/>
-              </a:lnSpc>
-              <a:buNone/>
-            </a:pPr>
-            <a:r>
-              <a:rPr lang="en-US" sz="1350" b="1" dirty="0">
-                <a:solidFill>
-                  <a:srgbClr val="0F172A"/>
-                </a:solidFill>
-                <a:latin typeface="Segoe UI" pitchFamily="34" charset="0"/>
-                <a:ea typeface="Segoe UI" pitchFamily="34" charset="-122"/>
-                <a:cs typeface="Segoe UI" pitchFamily="34" charset="-120"/>
-              </a:rPr>
-              <a:t>Is LOE / lab 1 / LOE_DB the only Oracle database?</a:t>
-            </a:r>
-            <a:endParaRPr lang="en-US" sz="1350" dirty="0"/>
-          </a:p>
-        </p:txBody>
-      </p:sp>
-      <p:sp>
-        <p:nvSpPr>
-          <p:cNvPr id="7" name="Text 5"/>
-          <p:cNvSpPr/>
-          <p:nvPr/>
-        </p:nvSpPr>
-        <p:spPr>
-          <a:xfrm>
-            <a:off x="1341120" y="3467862"/>
-            <a:ext cx="10003536" cy="171450"/>
-          </a:xfrm>
-          <a:prstGeom prst="rect">
-            <a:avLst/>
-          </a:prstGeom>
-          <a:noFill/>
-          <a:ln/>
-        </p:spPr>
-        <p:txBody>
-          <a:bodyPr wrap="square" lIns="0" tIns="0" rIns="0" bIns="0" rtlCol="0" anchor="t"/>
-          <a:lstStyle/>
-          <a:p>
-            <a:pPr algn="l" indent="0" marL="0">
-              <a:lnSpc>
-                <a:spcPct val="110000"/>
-              </a:lnSpc>
-              <a:buNone/>
-            </a:pPr>
-            <a:r>
-              <a:rPr lang="en-US" sz="1125" dirty="0">
-                <a:solidFill>
-                  <a:srgbClr val="64748B"/>
-                </a:solidFill>
-                <a:latin typeface="Segoe UI" pitchFamily="34" charset="0"/>
-                <a:ea typeface="Segoe UI" pitchFamily="34" charset="-122"/>
-                <a:cs typeface="Segoe UI" pitchFamily="34" charset="-120"/>
-              </a:rPr>
-              <a:t>The flag read will use that connection unless the thread is already on Oracle.</a:t>
-            </a:r>
-            <a:endParaRPr lang="en-US" sz="1125" dirty="0"/>
-          </a:p>
-        </p:txBody>
-      </p:sp>
-      <p:sp>
-        <p:nvSpPr>
-          <p:cNvPr id="8" name="Shape 6"/>
-          <p:cNvSpPr/>
-          <p:nvPr/>
-        </p:nvSpPr>
-        <p:spPr>
-          <a:xfrm>
-            <a:off x="609600" y="3950208"/>
-            <a:ext cx="10972800" cy="797814"/>
-          </a:xfrm>
-          <a:prstGeom prst="roundRect">
-            <a:avLst>
-              <a:gd name="adj" fmla="val 13754"/>
-            </a:avLst>
-          </a:prstGeom>
-          <a:solidFill>
-            <a:srgbClr val="FFFFFF"/>
-          </a:solidFill>
-          <a:ln w="9525">
-            <a:solidFill>
-              <a:srgbClr val="E2E8F0"/>
-            </a:solidFill>
-            <a:prstDash val="solid"/>
-          </a:ln>
-        </p:spPr>
-      </p:sp>
-      <p:sp>
-        <p:nvSpPr>
-          <p:cNvPr id="9" name="Text 7"/>
-          <p:cNvSpPr/>
-          <p:nvPr/>
-        </p:nvSpPr>
-        <p:spPr>
-          <a:xfrm>
-            <a:off x="847344" y="3950208"/>
-            <a:ext cx="502920" cy="797814"/>
-          </a:xfrm>
-          <a:prstGeom prst="rect">
-            <a:avLst/>
-          </a:prstGeom>
-          <a:noFill/>
-          <a:ln/>
-        </p:spPr>
-        <p:txBody>
-          <a:bodyPr wrap="square" lIns="0" tIns="0" rIns="0" bIns="0" rtlCol="0" anchor="ctr"/>
-          <a:lstStyle/>
-          <a:p>
-            <a:pPr algn="l" indent="0" marL="0">
-              <a:lnSpc>
-                <a:spcPct val="115000"/>
-              </a:lnSpc>
-              <a:buNone/>
-            </a:pPr>
-            <a:r>
-              <a:rPr lang="en-US" sz="1500" dirty="0">
-                <a:solidFill>
-                  <a:srgbClr val="0284C7"/>
-                </a:solidFill>
-                <a:latin typeface="Segoe UI Semibold" pitchFamily="34" charset="0"/>
-                <a:ea typeface="Segoe UI Semibold" pitchFamily="34" charset="-122"/>
-                <a:cs typeface="Segoe UI Semibold" pitchFamily="34" charset="-120"/>
-              </a:rPr>
-              <a:t>02</a:t>
-            </a:r>
-            <a:endParaRPr lang="en-US" sz="1500" dirty="0"/>
-          </a:p>
-        </p:txBody>
-      </p:sp>
-      <p:sp>
-        <p:nvSpPr>
-          <p:cNvPr id="10" name="Text 8"/>
-          <p:cNvSpPr/>
-          <p:nvPr/>
-        </p:nvSpPr>
-        <p:spPr>
-          <a:xfrm>
-            <a:off x="1341120" y="4133088"/>
-            <a:ext cx="10003536" cy="205740"/>
-          </a:xfrm>
-          <a:prstGeom prst="rect">
-            <a:avLst/>
-          </a:prstGeom>
-          <a:noFill/>
-          <a:ln/>
-        </p:spPr>
-        <p:txBody>
-          <a:bodyPr wrap="square" lIns="0" tIns="0" rIns="0" bIns="0" rtlCol="0" anchor="t"/>
-          <a:lstStyle/>
-          <a:p>
-            <a:pPr algn="l" indent="0" marL="0">
-              <a:lnSpc>
-                <a:spcPct val="110000"/>
-              </a:lnSpc>
-              <a:buNone/>
-            </a:pPr>
-            <a:r>
-              <a:rPr lang="en-US" sz="1350" b="1" dirty="0">
-                <a:solidFill>
-                  <a:srgbClr val="0F172A"/>
-                </a:solidFill>
-                <a:latin typeface="Segoe UI" pitchFamily="34" charset="0"/>
-                <a:ea typeface="Segoe UI" pitchFamily="34" charset="-122"/>
-                <a:cs typeface="Segoe UI" pitchFamily="34" charset="-120"/>
-              </a:rPr>
-              <a:t>If a distributed transaction is already open, may this Oracle read join it?</a:t>
-            </a:r>
-            <a:endParaRPr lang="en-US" sz="1350" dirty="0"/>
-          </a:p>
-        </p:txBody>
-      </p:sp>
-      <p:sp>
-        <p:nvSpPr>
-          <p:cNvPr id="11" name="Text 9"/>
-          <p:cNvSpPr/>
-          <p:nvPr/>
-        </p:nvSpPr>
-        <p:spPr>
-          <a:xfrm>
-            <a:off x="1341120" y="4393692"/>
-            <a:ext cx="10003536" cy="171450"/>
-          </a:xfrm>
-          <a:prstGeom prst="rect">
-            <a:avLst/>
-          </a:prstGeom>
-          <a:noFill/>
-          <a:ln/>
-        </p:spPr>
-        <p:txBody>
-          <a:bodyPr wrap="square" lIns="0" tIns="0" rIns="0" bIns="0" rtlCol="0" anchor="t"/>
-          <a:lstStyle/>
-          <a:p>
-            <a:pPr algn="l" indent="0" marL="0">
-              <a:lnSpc>
-                <a:spcPct val="110000"/>
-              </a:lnSpc>
-              <a:buNone/>
-            </a:pPr>
-            <a:r>
-              <a:rPr lang="en-US" sz="1125" dirty="0">
-                <a:solidFill>
-                  <a:srgbClr val="64748B"/>
-                </a:solidFill>
-                <a:latin typeface="Segoe UI" pitchFamily="34" charset="0"/>
-                <a:ea typeface="Segoe UI" pitchFamily="34" charset="-122"/>
-                <a:cs typeface="Segoe UI" pitchFamily="34" charset="-120"/>
-              </a:rPr>
-              <a:t>Hospital work will not be committed early. Transaction locking otherwise stays as LIS-10723 left it.</a:t>
-            </a:r>
-            <a:endParaRPr lang="en-US" sz="1125" dirty="0"/>
-          </a:p>
-        </p:txBody>
-      </p:sp>
-    </p:spTree>
-  </p:cSld>
-  <p:clrMapOvr>
-    <a:masterClrMapping/>
-  </p:clrMapOvr>
-</p:sld>
-</file>
-
-<file path=ppt/slides/slide8.xml><?xml version="1.0" encoding="utf-8"?>
-<p:sld xmlns:a="http://schemas.openxmlformats.org/drawingml/2006/main" xmlns:r="http://schemas.openxmlformats.org/officeDocument/2006/relationships" xmlns:p="http://schemas.openxmlformats.org/presentationml/2006/main">
-  <p:cSld name="Slide 8">
     <p:bg>
       <p:bgPr>
         <a:solidFill>
@@ -6503,8 +5909,8 @@
         </p:nvSpPr>
         <p:spPr>
           <a:xfrm>
-            <a:off x="758952" y="2722245"/>
-            <a:ext cx="9601200" cy="219456"/>
+            <a:off x="2237232" y="3014282"/>
+            <a:ext cx="7717536" cy="219456"/>
           </a:xfrm>
           <a:prstGeom prst="rect">
             <a:avLst/>
@@ -6516,7 +5922,7 @@
           <a:bodyPr wrap="square" lIns="0" tIns="0" rIns="0" bIns="0" rtlCol="0" anchor="t"/>
           <a:lstStyle/>
           <a:p>
-            <a:pPr algn="l" indent="0" marL="0">
+            <a:pPr algn="ctr" indent="0" marL="0">
               <a:lnSpc>
                 <a:spcPct val="115000"/>
               </a:lnSpc>
@@ -6545,8 +5951,8 @@
         </p:nvSpPr>
         <p:spPr>
           <a:xfrm>
-            <a:off x="758952" y="3069717"/>
-            <a:ext cx="9601200" cy="481965"/>
+            <a:off x="2237232" y="3361754"/>
+            <a:ext cx="7717536" cy="481965"/>
           </a:xfrm>
           <a:prstGeom prst="rect">
             <a:avLst/>
@@ -6558,7 +5964,7 @@
           <a:bodyPr wrap="square" lIns="0" tIns="0" rIns="0" bIns="0" rtlCol="0" anchor="t"/>
           <a:lstStyle/>
           <a:p>
-            <a:pPr algn="l" indent="0" marL="0">
+            <a:pPr algn="ctr" indent="0" marL="0">
               <a:lnSpc>
                 <a:spcPct val="105000"/>
               </a:lnSpc>
@@ -6576,465 +5982,6 @@
               <a:t>Q&amp;A</a:t>
             </a:r>
             <a:endParaRPr lang="en-US" sz="3300" dirty="0"/>
-          </a:p>
-        </p:txBody>
-      </p:sp>
-      <p:sp>
-        <p:nvSpPr>
-          <p:cNvPr id="4" name="Text 2"/>
-          <p:cNvSpPr/>
-          <p:nvPr/>
-        </p:nvSpPr>
-        <p:spPr>
-          <a:xfrm>
-            <a:off x="758952" y="3707130"/>
-            <a:ext cx="7315200" cy="428625"/>
-          </a:xfrm>
-          <a:prstGeom prst="rect">
-            <a:avLst/>
-          </a:prstGeom>
-          <a:noFill/>
-          <a:ln/>
-        </p:spPr>
-        <p:txBody>
-          <a:bodyPr wrap="square" lIns="0" tIns="0" rIns="0" bIns="0" rtlCol="0" anchor="t"/>
-          <a:lstStyle/>
-          <a:p>
-            <a:pPr algn="l" indent="0" marL="0">
-              <a:lnSpc>
-                <a:spcPct val="120000"/>
-              </a:lnSpc>
-              <a:buNone/>
-            </a:pPr>
-            <a:r>
-              <a:rPr lang="en-US" sz="1350" dirty="0">
-                <a:solidFill>
-                  <a:srgbClr val="94A3B8"/>
-                </a:solidFill>
-                <a:latin typeface="Segoe UI" pitchFamily="34" charset="0"/>
-                <a:ea typeface="Segoe UI" pitchFamily="34" charset="-122"/>
-                <a:cs typeface="Segoe UI" pitchFamily="34" charset="-120"/>
-              </a:rPr>
-              <a:t>Patient sync source does not change. The strip runs again once the Oracle flag can be read.</a:t>
-            </a:r>
-            <a:endParaRPr lang="en-US" sz="1350" dirty="0"/>
-          </a:p>
-        </p:txBody>
-      </p:sp>
-    </p:spTree>
-  </p:cSld>
-  <p:clrMapOvr>
-    <a:masterClrMapping/>
-  </p:clrMapOvr>
-</p:sld>
-</file>
-
-<file path=ppt/slides/slide9.xml><?xml version="1.0" encoding="utf-8"?>
-<p:sld xmlns:a="http://schemas.openxmlformats.org/drawingml/2006/main" xmlns:r="http://schemas.openxmlformats.org/officeDocument/2006/relationships" xmlns:p="http://schemas.openxmlformats.org/presentationml/2006/main">
-  <p:cSld name="Slide 9">
-    <p:bg>
-      <p:bgPr>
-        <a:solidFill>
-          <a:srgbClr val="090D16"/>
-        </a:solidFill>
-      </p:bgPr>
-    </p:bg>
-    <p:spTree>
-      <p:nvGrpSpPr>
-        <p:cNvPr id="1" name=""/>
-        <p:cNvGrpSpPr/>
-        <p:nvPr/>
-      </p:nvGrpSpPr>
-      <p:grpSpPr>
-        <a:xfrm>
-          <a:off x="0" y="0"/>
-          <a:ext cx="0" cy="0"/>
-          <a:chOff x="0" y="0"/>
-          <a:chExt cx="0" cy="0"/>
-        </a:xfrm>
-      </p:grpSpPr>
-      <p:sp>
-        <p:nvSpPr>
-          <p:cNvPr id="2" name="Shape 0"/>
-          <p:cNvSpPr/>
-          <p:nvPr/>
-        </p:nvSpPr>
-        <p:spPr>
-          <a:xfrm>
-            <a:off x="5867400" y="2052161"/>
-            <a:ext cx="457200" cy="457200"/>
-          </a:xfrm>
-          <a:prstGeom prst="ellipse">
-            <a:avLst/>
-          </a:prstGeom>
-          <a:solidFill>
-            <a:srgbClr val="082F49"/>
-          </a:solidFill>
-          <a:ln w="12700">
-            <a:solidFill>
-              <a:srgbClr val="082F49"/>
-            </a:solidFill>
-            <a:prstDash val="solid"/>
-          </a:ln>
-        </p:spPr>
-      </p:sp>
-      <p:pic>
-        <p:nvPicPr>
-          <p:cNvPr id="3" name="Image 0" descr="D:\Github\HA-Notes\LIS\skills\design-review-pptx\assets\icons\png\onDark\clipboard-check.png">    </p:cNvPr>
-          <p:cNvPicPr>
-            <a:picLocks noChangeAspect="1"/>
-          </p:cNvPicPr>
-          <p:nvPr/>
-        </p:nvPicPr>
-        <p:blipFill>
-          <a:blip r:embed="rId1"/>
-          <a:stretch>
-            <a:fillRect/>
-          </a:stretch>
-        </p:blipFill>
-        <p:spPr>
-          <a:xfrm>
-            <a:off x="5981700" y="2166461"/>
-            <a:ext cx="228600" cy="228600"/>
-          </a:xfrm>
-          <a:prstGeom prst="rect">
-            <a:avLst/>
-          </a:prstGeom>
-        </p:spPr>
-      </p:pic>
-      <p:sp>
-        <p:nvSpPr>
-          <p:cNvPr id="4" name="Text 1"/>
-          <p:cNvSpPr/>
-          <p:nvPr/>
-        </p:nvSpPr>
-        <p:spPr>
-          <a:xfrm>
-            <a:off x="1752600" y="2701385"/>
-            <a:ext cx="8686800" cy="481965"/>
-          </a:xfrm>
-          <a:prstGeom prst="rect">
-            <a:avLst/>
-          </a:prstGeom>
-          <a:noFill/>
-          <a:ln/>
-        </p:spPr>
-        <p:txBody>
-          <a:bodyPr wrap="square" lIns="0" tIns="0" rIns="0" bIns="0" rtlCol="0" anchor="t"/>
-          <a:lstStyle/>
-          <a:p>
-            <a:pPr algn="ctr" indent="0" marL="0">
-              <a:lnSpc>
-                <a:spcPct val="105000"/>
-              </a:lnSpc>
-              <a:buNone/>
-            </a:pPr>
-            <a:r>
-              <a:rPr lang="en-US" sz="3300" dirty="0">
-                <a:solidFill>
-                  <a:srgbClr val="FFFFFF"/>
-                </a:solidFill>
-                <a:latin typeface="Segoe UI Semibold" pitchFamily="34" charset="0"/>
-                <a:ea typeface="Segoe UI Semibold" pitchFamily="34" charset="-122"/>
-                <a:cs typeface="Segoe UI Semibold" pitchFamily="34" charset="-120"/>
-              </a:rPr>
-              <a:t>Read the flag, then strip for Sybase</a:t>
-            </a:r>
-            <a:endParaRPr lang="en-US" sz="3300" dirty="0"/>
-          </a:p>
-        </p:txBody>
-      </p:sp>
-      <p:sp>
-        <p:nvSpPr>
-          <p:cNvPr id="5" name="Text 2"/>
-          <p:cNvSpPr/>
-          <p:nvPr/>
-        </p:nvSpPr>
-        <p:spPr>
-          <a:xfrm>
-            <a:off x="2406396" y="3338798"/>
-            <a:ext cx="7379208" cy="214313"/>
-          </a:xfrm>
-          <a:prstGeom prst="rect">
-            <a:avLst/>
-          </a:prstGeom>
-          <a:noFill/>
-          <a:ln/>
-        </p:spPr>
-        <p:txBody>
-          <a:bodyPr wrap="square" lIns="0" tIns="0" rIns="0" bIns="0" rtlCol="0" anchor="t"/>
-          <a:lstStyle/>
-          <a:p>
-            <a:pPr algn="ctr" indent="0" marL="0">
-              <a:lnSpc>
-                <a:spcPct val="120000"/>
-              </a:lnSpc>
-              <a:buNone/>
-            </a:pPr>
-            <a:r>
-              <a:rPr lang="en-US" sz="1350" dirty="0">
-                <a:solidFill>
-                  <a:srgbClr val="94A3B8"/>
-                </a:solidFill>
-                <a:latin typeface="Segoe UI" pitchFamily="34" charset="0"/>
-                <a:ea typeface="Segoe UI" pitchFamily="34" charset="-122"/>
-                <a:cs typeface="Segoe UI" pitchFamily="34" charset="-120"/>
-              </a:rPr>
-              <a:t>No schema change. No config change.</a:t>
-            </a:r>
-            <a:endParaRPr lang="en-US" sz="1350" dirty="0"/>
-          </a:p>
-        </p:txBody>
-      </p:sp>
-      <p:sp>
-        <p:nvSpPr>
-          <p:cNvPr id="6" name="Text 3"/>
-          <p:cNvSpPr/>
-          <p:nvPr/>
-        </p:nvSpPr>
-        <p:spPr>
-          <a:xfrm>
-            <a:off x="2548128" y="3937159"/>
-            <a:ext cx="3291840" cy="182880"/>
-          </a:xfrm>
-          <a:prstGeom prst="rect">
-            <a:avLst/>
-          </a:prstGeom>
-          <a:noFill/>
-          <a:ln/>
-        </p:spPr>
-        <p:txBody>
-          <a:bodyPr wrap="square" lIns="0" tIns="0" rIns="0" bIns="0" rtlCol="0" anchor="t"/>
-          <a:lstStyle/>
-          <a:p>
-            <a:pPr algn="l" indent="0" marL="0">
-              <a:lnSpc>
-                <a:spcPct val="115000"/>
-              </a:lnSpc>
-              <a:buNone/>
-            </a:pPr>
-            <a:r>
-              <a:rPr lang="en-US" sz="1050" dirty="0">
-                <a:solidFill>
-                  <a:srgbClr val="64748B"/>
-                </a:solidFill>
-                <a:latin typeface="Segoe UI" pitchFamily="34" charset="0"/>
-                <a:ea typeface="Segoe UI" pitchFamily="34" charset="-122"/>
-                <a:cs typeface="Segoe UI" pitchFamily="34" charset="-120"/>
-              </a:rPr>
-              <a:t>AFTER CP3</a:t>
-            </a:r>
-            <a:endParaRPr lang="en-US" sz="1050" dirty="0"/>
-          </a:p>
-        </p:txBody>
-      </p:sp>
-      <p:sp>
-        <p:nvSpPr>
-          <p:cNvPr id="7" name="Text 4"/>
-          <p:cNvSpPr/>
-          <p:nvPr/>
-        </p:nvSpPr>
-        <p:spPr>
-          <a:xfrm>
-            <a:off x="2548128" y="4156615"/>
-            <a:ext cx="3291840" cy="640080"/>
-          </a:xfrm>
-          <a:prstGeom prst="rect">
-            <a:avLst/>
-          </a:prstGeom>
-          <a:noFill/>
-          <a:ln/>
-        </p:spPr>
-        <p:txBody>
-          <a:bodyPr wrap="square" lIns="0" tIns="0" rIns="0" bIns="0" rtlCol="0" anchor="t"/>
-          <a:lstStyle/>
-          <a:p>
-            <a:pPr algn="l" indent="0" marL="0">
-              <a:lnSpc>
-                <a:spcPct val="115000"/>
-              </a:lnSpc>
-              <a:buNone/>
-            </a:pPr>
-            <a:r>
-              <a:rPr lang="en-US" sz="1200" dirty="0">
-                <a:solidFill>
-                  <a:srgbClr val="F1F5F9"/>
-                </a:solidFill>
-                <a:latin typeface="Segoe UI" pitchFamily="34" charset="0"/>
-                <a:ea typeface="Segoe UI" pitchFamily="34" charset="-122"/>
-                <a:cs typeface="Segoe UI" pitchFamily="34" charset="-120"/>
-              </a:rPr>
-              <a:t>Write actions back onto the design note</a:t>
-            </a:r>
-            <a:endParaRPr lang="en-US" sz="1200" dirty="0"/>
-          </a:p>
-        </p:txBody>
-      </p:sp>
-      <p:sp>
-        <p:nvSpPr>
-          <p:cNvPr id="8" name="Shape 5"/>
-          <p:cNvSpPr/>
-          <p:nvPr/>
-        </p:nvSpPr>
-        <p:spPr>
-          <a:xfrm>
-            <a:off x="6096000" y="3937159"/>
-            <a:ext cx="10973" cy="566928"/>
-          </a:xfrm>
-          <a:prstGeom prst="rect">
-            <a:avLst/>
-          </a:prstGeom>
-          <a:solidFill>
-            <a:srgbClr val="1E293B"/>
-          </a:solidFill>
-          <a:ln w="12700">
-            <a:solidFill>
-              <a:srgbClr val="1E293B"/>
-            </a:solidFill>
-            <a:prstDash val="solid"/>
-          </a:ln>
-        </p:spPr>
-      </p:sp>
-      <p:sp>
-        <p:nvSpPr>
-          <p:cNvPr id="9" name="Text 6"/>
-          <p:cNvSpPr/>
-          <p:nvPr/>
-        </p:nvSpPr>
-        <p:spPr>
-          <a:xfrm>
-            <a:off x="6352032" y="3937159"/>
-            <a:ext cx="3291840" cy="182880"/>
-          </a:xfrm>
-          <a:prstGeom prst="rect">
-            <a:avLst/>
-          </a:prstGeom>
-          <a:noFill/>
-          <a:ln/>
-        </p:spPr>
-        <p:txBody>
-          <a:bodyPr wrap="square" lIns="0" tIns="0" rIns="0" bIns="0" rtlCol="0" anchor="t"/>
-          <a:lstStyle/>
-          <a:p>
-            <a:pPr algn="l" indent="0" marL="0">
-              <a:lnSpc>
-                <a:spcPct val="115000"/>
-              </a:lnSpc>
-              <a:buNone/>
-            </a:pPr>
-            <a:r>
-              <a:rPr lang="en-US" sz="1050" dirty="0">
-                <a:solidFill>
-                  <a:srgbClr val="64748B"/>
-                </a:solidFill>
-                <a:latin typeface="Segoe UI" pitchFamily="34" charset="0"/>
-                <a:ea typeface="Segoe UI" pitchFamily="34" charset="-122"/>
-                <a:cs typeface="Segoe UI" pitchFamily="34" charset="-120"/>
-              </a:rPr>
-              <a:t>THEN BUILD</a:t>
-            </a:r>
-            <a:endParaRPr lang="en-US" sz="1050" dirty="0"/>
-          </a:p>
-        </p:txBody>
-      </p:sp>
-      <p:sp>
-        <p:nvSpPr>
-          <p:cNvPr id="10" name="Text 7"/>
-          <p:cNvSpPr/>
-          <p:nvPr/>
-        </p:nvSpPr>
-        <p:spPr>
-          <a:xfrm>
-            <a:off x="6352032" y="4156615"/>
-            <a:ext cx="3291840" cy="640080"/>
-          </a:xfrm>
-          <a:prstGeom prst="rect">
-            <a:avLst/>
-          </a:prstGeom>
-          <a:noFill/>
-          <a:ln/>
-        </p:spPr>
-        <p:txBody>
-          <a:bodyPr wrap="square" lIns="0" tIns="0" rIns="0" bIns="0" rtlCol="0" anchor="t"/>
-          <a:lstStyle/>
-          <a:p>
-            <a:pPr algn="l" indent="0" marL="0">
-              <a:lnSpc>
-                <a:spcPct val="115000"/>
-              </a:lnSpc>
-              <a:buNone/>
-            </a:pPr>
-            <a:r>
-              <a:rPr lang="en-US" sz="1200" dirty="0">
-                <a:solidFill>
-                  <a:srgbClr val="F1F5F9"/>
-                </a:solidFill>
-                <a:latin typeface="Segoe UI" pitchFamily="34" charset="0"/>
-                <a:ea typeface="Segoe UI" pitchFamily="34" charset="-122"/>
-                <a:cs typeface="Segoe UI" pitchFamily="34" charset="-120"/>
-              </a:rPr>
-              <a:t>data-source only</a:t>
-            </a:r>
-            <a:endParaRPr lang="en-US" sz="1200" dirty="0"/>
-          </a:p>
-        </p:txBody>
-      </p:sp>
-      <p:sp>
-        <p:nvSpPr>
-          <p:cNvPr id="11" name="Text 8"/>
-          <p:cNvSpPr/>
-          <p:nvPr/>
-        </p:nvSpPr>
-        <p:spPr>
-          <a:xfrm>
-            <a:off x="758952" y="6089904"/>
-            <a:ext cx="10674096" cy="237744"/>
-          </a:xfrm>
-          <a:prstGeom prst="rect">
-            <a:avLst/>
-          </a:prstGeom>
-          <a:noFill/>
-          <a:ln/>
-        </p:spPr>
-        <p:txBody>
-          <a:bodyPr wrap="square" lIns="0" tIns="0" rIns="0" bIns="0" rtlCol="0" anchor="t"/>
-          <a:lstStyle/>
-          <a:p>
-            <a:pPr algn="ctr" indent="0" marL="0">
-              <a:lnSpc>
-                <a:spcPct val="120000"/>
-              </a:lnSpc>
-              <a:buNone/>
-            </a:pPr>
-            <a:r>
-              <a:rPr lang="en-US" sz="1125" dirty="0">
-                <a:solidFill>
-                  <a:srgbClr val="38BDF8"/>
-                </a:solidFill>
-                <a:latin typeface="Consolas" pitchFamily="34" charset="0"/>
-                <a:ea typeface="Consolas" pitchFamily="34" charset="-122"/>
-                <a:cs typeface="Consolas" pitchFamily="34" charset="-120"/>
-              </a:rPr>
-              <a:t>TMP-oracle-route-lookup   </a:t>
-            </a:r>
-            <a:pPr algn="ctr" indent="0" marL="0">
-              <a:lnSpc>
-                <a:spcPct val="120000"/>
-              </a:lnSpc>
-              <a:buNone/>
-            </a:pPr>
-            <a:r>
-              <a:rPr lang="en-US" sz="1125" dirty="0">
-                <a:solidFill>
-                  <a:srgbClr val="64748B"/>
-                </a:solidFill>
-                <a:latin typeface="Segoe UI" pitchFamily="34" charset="0"/>
-                <a:ea typeface="Segoe UI" pitchFamily="34" charset="-122"/>
-                <a:cs typeface="Segoe UI" pitchFamily="34" charset="-120"/>
-              </a:rPr>
-              <a:t>lis-patient-pmi-sync-svc  ·  LIS-10723</a:t>
-            </a:r>
-            <a:endParaRPr lang="en-US" sz="1125" dirty="0"/>
           </a:p>
         </p:txBody>
       </p:sp>

</xml_diff>

<commit_message>
vault backup: 2026-09-25 14:32:51
</commit_message>
<xml_diff>
--- a/SDLC/Projects/TMP-oracle-route-lookup — Oracle route lookup/assets/Oracle route lookup.pptx
+++ b/SDLC/Projects/TMP-oracle-route-lookup — Oracle route lookup/assets/Oracle route lookup.pptx
@@ -508,7 +508,7 @@
           <a:p>
             <a:r>
               <a:rPr lang="en-US" dirty="0"/>
-              <a:t>Patient sync is supposed to strip Chinese characters when the hospital is on Sybase. After the LIS-10723 data-source upgrade, the flag check does not reach Oracle, so the strip never runs.</a:t>
+              <a:t>Patient sync is supposed to remove Chinese characters when the hospital is on Sybase. After the LIS-10723 data-source upgrade, the flag check does not reach Oracle, so they are not removed.</a:t>
             </a:r>
             <a:endParaRPr lang="en-US" dirty="0"/>
           </a:p>
@@ -684,7 +684,7 @@
           <a:p>
             <a:r>
               <a:rPr lang="en-US" dirty="0"/>
-              <a:t>The flag is the only thing that turns the strip on. When the check fails, the program skips the replace and Sybase gets the Chinese characters.</a:t>
+              <a:t>The flag is the only thing that decides whether to remove. When the check fails, the program skips the replace and Sybase gets the Chinese characters.</a:t>
             </a:r>
             <a:endParaRPr lang="en-US" dirty="0"/>
           </a:p>
@@ -1036,7 +1036,7 @@
           <a:p>
             <a:r>
               <a:rPr lang="en-US" dirty="0"/>
-              <a:t>Likely question: does patient sync source change? No. The strip is already there. It runs again once the Oracle flag can be read.</a:t>
+              <a:t>Likely question: does patient sync source change? No. The logic to remove Chinese characters is already there. It runs again once the Oracle flag can be read.</a:t>
             </a:r>
             <a:endParaRPr lang="en-US" dirty="0"/>
           </a:p>
@@ -1610,7 +1610,7 @@
                 <a:ea typeface="Segoe UI" pitchFamily="34" charset="-122"/>
                 <a:cs typeface="Segoe UI" pitchFamily="34" charset="-120"/>
               </a:rPr>
-              <a:t>lis-patient-pmi-sync-svc strips Chinese characters when the hospital is on Sybase. After the LIS-10723 data-source upgrade, that flag check does not reach Oracle, so the strip is skipped.</a:t>
+              <a:t>lis-patient-pmi-sync-svc removes Chinese characters when the hospital is on Sybase. After the LIS-10723 data-source upgrade, that flag check does not reach Oracle, so they are not removed.</a:t>
             </a:r>
             <a:endParaRPr lang="en-US" sz="1500" dirty="0"/>
           </a:p>
@@ -2741,7 +2741,7 @@
                 <a:ea typeface="Segoe UI" pitchFamily="34" charset="-122"/>
                 <a:cs typeface="Segoe UI" pitchFamily="34" charset="-120"/>
               </a:rPr>
-              <a:t>read the flag, then strip when Sybase</a:t>
+              <a:t>read the flag, then remove when Sybase</a:t>
             </a:r>
             <a:endParaRPr lang="en-US" sz="1125" dirty="0"/>
           </a:p>
@@ -3157,7 +3157,7 @@
                 <a:ea typeface="Segoe UI Semibold" pitchFamily="34" charset="-122"/>
                 <a:cs typeface="Segoe UI Semibold" pitchFamily="34" charset="-120"/>
               </a:rPr>
-              <a:t>The strip is skipped, so Chinese characters land in Sybase</a:t>
+              <a:t>Chinese characters are not removed, so they land in Sybase</a:t>
             </a:r>
             <a:endParaRPr lang="en-US" sz="2400" dirty="0"/>
           </a:p>
@@ -3268,7 +3268,7 @@
                 <a:ea typeface="Consolas" pitchFamily="34" charset="-122"/>
                 <a:cs typeface="Consolas" pitchFamily="34" charset="-120"/>
               </a:rPr>
-              <a:t>Patient sync</a:t>
+              <a:t>Patient PMI Sync</a:t>
             </a:r>
             <a:endParaRPr lang="en-US" sz="1125" dirty="0"/>
           </a:p>
@@ -3310,7 +3310,7 @@
                 <a:ea typeface="Segoe UI Semibold" pitchFamily="34" charset="-122"/>
                 <a:cs typeface="Segoe UI Semibold" pitchFamily="34" charset="-120"/>
               </a:rPr>
-              <a:t>Chinese characters are stripped for Sybase</a:t>
+              <a:t>Non-ASCII characters are removed for Sybase</a:t>
             </a:r>
             <a:endParaRPr lang="en-US" sz="1500" dirty="0"/>
           </a:p>
@@ -3750,7 +3750,7 @@
                 <a:ea typeface="Segoe UI Semibold" pitchFamily="34" charset="-122"/>
                 <a:cs typeface="Segoe UI Semibold" pitchFamily="34" charset="-120"/>
               </a:rPr>
-              <a:t>The strip does not run</a:t>
+              <a:t>Characters are not removed</a:t>
             </a:r>
             <a:endParaRPr lang="en-US" sz="1500" dirty="0"/>
           </a:p>
@@ -3834,7 +3834,7 @@
                 <a:ea typeface="Segoe UI" pitchFamily="34" charset="-122"/>
                 <a:cs typeface="Segoe UI" pitchFamily="34" charset="-120"/>
               </a:rPr>
-              <a:t>What decides the strip:  </a:t>
+              <a:t>What decides whether to remove:  </a:t>
             </a:r>
             <a:pPr algn="l" indent="0" marL="0">
               <a:lnSpc>
@@ -4077,7 +4077,7 @@
                 <a:ea typeface="Segoe UI Semibold" pitchFamily="34" charset="-122"/>
                 <a:cs typeface="Segoe UI Semibold" pitchFamily="34" charset="-120"/>
               </a:rPr>
-              <a:t>The strip is skipped</a:t>
+              <a:t>Characters are not removed</a:t>
             </a:r>
             <a:endParaRPr lang="en-US" sz="1500" dirty="0"/>
           </a:p>
@@ -4640,7 +4640,7 @@
                 <a:ea typeface="Segoe UI Semibold" pitchFamily="34" charset="-122"/>
                 <a:cs typeface="Segoe UI Semibold" pitchFamily="34" charset="-120"/>
               </a:rPr>
-              <a:t>Read the Oracle flag, then strip when the hospital is Sybase</a:t>
+              <a:t>Read the Oracle flag, then remove when the hospital is Sybase</a:t>
             </a:r>
             <a:endParaRPr lang="en-US" sz="2400" dirty="0"/>
           </a:p>

</xml_diff>

<commit_message>
vault backup: 2026-09-25 14:40:18
</commit_message>
<xml_diff>
--- a/SDLC/Projects/TMP-oracle-route-lookup — Oracle route lookup/assets/Oracle route lookup.pptx
+++ b/SDLC/Projects/TMP-oracle-route-lookup — Oracle route lookup/assets/Oracle route lookup.pptx
@@ -1418,7 +1418,7 @@
         <p:spPr>
           <a:xfrm>
             <a:off x="758952" y="1835849"/>
-            <a:ext cx="3772662" cy="228600"/>
+            <a:ext cx="8574786" cy="228600"/>
           </a:xfrm>
           <a:prstGeom prst="rect">
             <a:avLst/>
@@ -1442,7 +1442,7 @@
                 <a:ea typeface="Segoe UI Semibold" pitchFamily="34" charset="-122"/>
                 <a:cs typeface="Segoe UI Semibold" pitchFamily="34" charset="-120"/>
               </a:rPr>
-              <a:t>TMP-ORACLE-ROUTE-LOOKUP</a:t>
+              <a:t>TMP-FAILURE-IN-REMOVING-CHINESE-CHARACTER-IN-LIS-PATIENT-PMI-SYNC-SVC</a:t>
             </a:r>
             <a:endParaRPr lang="en-US" sz="1050" dirty="0"/>
           </a:p>
@@ -1456,7 +1456,7 @@
         </p:nvSpPr>
         <p:spPr>
           <a:xfrm>
-            <a:off x="3269742" y="1950149"/>
+            <a:off x="8071866" y="1950149"/>
             <a:ext cx="301752" cy="10973"/>
           </a:xfrm>
           <a:prstGeom prst="rect">
@@ -1481,8 +1481,8 @@
         </p:nvSpPr>
         <p:spPr>
           <a:xfrm>
-            <a:off x="3690366" y="1835849"/>
-            <a:ext cx="7892034" cy="228600"/>
+            <a:off x="8492490" y="1835849"/>
+            <a:ext cx="3089910" cy="228600"/>
           </a:xfrm>
           <a:prstGeom prst="rect">
             <a:avLst/>

</xml_diff>